<commit_message>
Día 5 y 6 Módulo 4: código Go a Node.js + slides de respuestas al debate y repaso
</commit_message>
<xml_diff>
--- a/docs/slides/Modulo 4/dia_6.pptx
+++ b/docs/slides/Modulo 4/dia_6.pptx
@@ -27,6 +27,10 @@
     <p:sldId id="275" r:id="rId21"/>
     <p:sldId id="276" r:id="rId22"/>
     <p:sldId id="277" r:id="rId23"/>
+    <p:sldId id="278" r:id="rId28"/>
+    <p:sldId id="279" r:id="rId29"/>
+    <p:sldId id="280" r:id="rId30"/>
+    <p:sldId id="281" r:id="rId31"/>
   </p:sldIdLst>
   <p:sldSz cx="12188825" cy="6858000"/>
   <p:notesSz cx="6858000" cy="9144000"/>
@@ -4031,7 +4035,7 @@
               </a:defRPr>
             </a:pPr>
             <a:r>
-              <a:t>Unit test con mock del Stub (Go)</a:t>
+              <a:t>Unit test con mock del Stub (Node.js)</a:t>
             </a:r>
           </a:p>
         </p:txBody>
@@ -4143,7 +4147,7 @@
               </a:defRPr>
             </a:pPr>
             <a:r>
-              <a:t>GO</a:t>
+              <a:t>NODE.JS</a:t>
             </a:r>
           </a:p>
         </p:txBody>
@@ -4212,15 +4216,7 @@
           <a:bodyPr wrap="square"/>
           <a:lstStyle/>
           <a:p>
-            <a:br>
-              <a:rPr sz="1600" dirty="0">
-                <a:solidFill>
-                  <a:schemeClr val="bg1">
-                    <a:lumMod val="95000"/>
-                  </a:schemeClr>
-                </a:solidFill>
-              </a:rPr>
-            </a:br>
+            <a:pPr/>
             <a:r>
               <a:rPr sz="1600" dirty="0" err="1">
                 <a:solidFill>
@@ -4229,18 +4225,11 @@
                   </a:schemeClr>
                 </a:solidFill>
               </a:rPr>
-              <a:t>func</a:t>
-            </a:r>
-            <a:r>
-              <a:rPr sz="1600" dirty="0">
-                <a:solidFill>
-                  <a:schemeClr val="bg1">
-                    <a:lumMod val="95000"/>
-                  </a:schemeClr>
-                </a:solidFill>
-              </a:rPr>
-              <a:t> </a:t>
-            </a:r>
+              <a:t>const { expect } = require('chai');</a:t>
+            </a:r>
+          </a:p>
+          <a:p>
+            <a:pPr/>
             <a:r>
               <a:rPr sz="1600" dirty="0" err="1">
                 <a:solidFill>
@@ -4249,18 +4238,11 @@
                   </a:schemeClr>
                 </a:solidFill>
               </a:rPr>
-              <a:t>TestCreateProperty</a:t>
-            </a:r>
-            <a:r>
-              <a:rPr sz="1600" dirty="0">
-                <a:solidFill>
-                  <a:schemeClr val="bg1">
-                    <a:lumMod val="95000"/>
-                  </a:schemeClr>
-                </a:solidFill>
-              </a:rPr>
-              <a:t>(t *</a:t>
-            </a:r>
+              <a:t>const sinon = require('sinon');</a:t>
+            </a:r>
+          </a:p>
+          <a:p>
+            <a:pPr/>
             <a:r>
               <a:rPr sz="1600" dirty="0" err="1">
                 <a:solidFill>
@@ -4269,37 +4251,11 @@
                   </a:schemeClr>
                 </a:solidFill>
               </a:rPr>
-              <a:t>testing.T</a:t>
-            </a:r>
-            <a:r>
-              <a:rPr sz="1600" dirty="0">
-                <a:solidFill>
-                  <a:schemeClr val="bg1">
-                    <a:lumMod val="95000"/>
-                  </a:schemeClr>
-                </a:solidFill>
-              </a:rPr>
-              <a:t>) {</a:t>
-            </a:r>
-            <a:br>
-              <a:rPr sz="1600" dirty="0">
-                <a:solidFill>
-                  <a:schemeClr val="bg1">
-                    <a:lumMod val="95000"/>
-                  </a:schemeClr>
-                </a:solidFill>
-              </a:rPr>
-            </a:br>
-            <a:r>
-              <a:rPr sz="1600" dirty="0">
-                <a:solidFill>
-                  <a:schemeClr val="bg1">
-                    <a:lumMod val="95000"/>
-                  </a:schemeClr>
-                </a:solidFill>
-              </a:rPr>
-              <a:t>    // Crear mock del </a:t>
-            </a:r>
+              <a:t>const { SmartContract } = require('../lib/smartContract');</a:t>
+            </a:r>
+          </a:p>
+          <a:p>
+            <a:pPr/>
             <a:r>
               <a:rPr sz="1600" dirty="0" err="1">
                 <a:solidFill>
@@ -4308,37 +4264,11 @@
                   </a:schemeClr>
                 </a:solidFill>
               </a:rPr>
-              <a:t>TransactionContext</a:t>
-            </a:r>
-            <a:r>
-              <a:rPr sz="1600" dirty="0">
-                <a:solidFill>
-                  <a:schemeClr val="bg1">
-                    <a:lumMod val="95000"/>
-                  </a:schemeClr>
-                </a:solidFill>
-              </a:rPr>
-              <a:t> y del Stub</a:t>
-            </a:r>
-            <a:br>
-              <a:rPr sz="1600" dirty="0">
-                <a:solidFill>
-                  <a:schemeClr val="bg1">
-                    <a:lumMod val="95000"/>
-                  </a:schemeClr>
-                </a:solidFill>
-              </a:rPr>
-            </a:br>
-            <a:r>
-              <a:rPr sz="1600" dirty="0">
-                <a:solidFill>
-                  <a:schemeClr val="bg1">
-                    <a:lumMod val="95000"/>
-                  </a:schemeClr>
-                </a:solidFill>
-              </a:rPr>
-              <a:t>    </a:t>
-            </a:r>
+              <a:t/>
+            </a:r>
+          </a:p>
+          <a:p>
+            <a:pPr/>
             <a:r>
               <a:rPr sz="1600" dirty="0" err="1">
                 <a:solidFill>
@@ -4347,18 +4277,11 @@
                   </a:schemeClr>
                 </a:solidFill>
               </a:rPr>
-              <a:t>mockCtx</a:t>
-            </a:r>
-            <a:r>
-              <a:rPr sz="1600" dirty="0">
-                <a:solidFill>
-                  <a:schemeClr val="bg1">
-                    <a:lumMod val="95000"/>
-                  </a:schemeClr>
-                </a:solidFill>
-              </a:rPr>
-              <a:t> := new(</a:t>
-            </a:r>
+              <a:t>describe('CreateProperty', () =&gt; {</a:t>
+            </a:r>
+          </a:p>
+          <a:p>
+            <a:pPr/>
             <a:r>
               <a:rPr sz="1600" dirty="0" err="1">
                 <a:solidFill>
@@ -4367,37 +4290,11 @@
                   </a:schemeClr>
                 </a:solidFill>
               </a:rPr>
-              <a:t>mocks.TransactionContext</a:t>
-            </a:r>
-            <a:r>
-              <a:rPr sz="1600" dirty="0">
-                <a:solidFill>
-                  <a:schemeClr val="bg1">
-                    <a:lumMod val="95000"/>
-                  </a:schemeClr>
-                </a:solidFill>
-              </a:rPr>
-              <a:t>)</a:t>
-            </a:r>
-            <a:br>
-              <a:rPr sz="1600" dirty="0">
-                <a:solidFill>
-                  <a:schemeClr val="bg1">
-                    <a:lumMod val="95000"/>
-                  </a:schemeClr>
-                </a:solidFill>
-              </a:rPr>
-            </a:br>
-            <a:r>
-              <a:rPr sz="1600" dirty="0">
-                <a:solidFill>
-                  <a:schemeClr val="bg1">
-                    <a:lumMod val="95000"/>
-                  </a:schemeClr>
-                </a:solidFill>
-              </a:rPr>
-              <a:t>    </a:t>
-            </a:r>
+              <a:t>    let ctx, stub, identity;</a:t>
+            </a:r>
+          </a:p>
+          <a:p>
+            <a:pPr/>
             <a:r>
               <a:rPr sz="1600" dirty="0" err="1">
                 <a:solidFill>
@@ -4406,18 +4303,11 @@
                   </a:schemeClr>
                 </a:solidFill>
               </a:rPr>
-              <a:t>mockStub</a:t>
-            </a:r>
-            <a:r>
-              <a:rPr sz="1600" dirty="0">
-                <a:solidFill>
-                  <a:schemeClr val="bg1">
-                    <a:lumMod val="95000"/>
-                  </a:schemeClr>
-                </a:solidFill>
-              </a:rPr>
-              <a:t> := new(</a:t>
-            </a:r>
+              <a:t/>
+            </a:r>
+          </a:p>
+          <a:p>
+            <a:pPr/>
             <a:r>
               <a:rPr sz="1600" dirty="0" err="1">
                 <a:solidFill>
@@ -4426,37 +4316,11 @@
                   </a:schemeClr>
                 </a:solidFill>
               </a:rPr>
-              <a:t>mocks.ChaincodeStub</a:t>
-            </a:r>
-            <a:r>
-              <a:rPr sz="1600" dirty="0">
-                <a:solidFill>
-                  <a:schemeClr val="bg1">
-                    <a:lumMod val="95000"/>
-                  </a:schemeClr>
-                </a:solidFill>
-              </a:rPr>
-              <a:t>)</a:t>
-            </a:r>
-            <a:br>
-              <a:rPr sz="1600" dirty="0">
-                <a:solidFill>
-                  <a:schemeClr val="bg1">
-                    <a:lumMod val="95000"/>
-                  </a:schemeClr>
-                </a:solidFill>
-              </a:rPr>
-            </a:br>
-            <a:r>
-              <a:rPr sz="1600" dirty="0">
-                <a:solidFill>
-                  <a:schemeClr val="bg1">
-                    <a:lumMod val="95000"/>
-                  </a:schemeClr>
-                </a:solidFill>
-              </a:rPr>
-              <a:t>    </a:t>
-            </a:r>
+              <a:t>    beforeEach(() =&gt; {</a:t>
+            </a:r>
+          </a:p>
+          <a:p>
+            <a:pPr/>
             <a:r>
               <a:rPr sz="1600" dirty="0" err="1">
                 <a:solidFill>
@@ -4465,18 +4329,11 @@
                   </a:schemeClr>
                 </a:solidFill>
               </a:rPr>
-              <a:t>mockIdentity</a:t>
-            </a:r>
-            <a:r>
-              <a:rPr sz="1600" dirty="0">
-                <a:solidFill>
-                  <a:schemeClr val="bg1">
-                    <a:lumMod val="95000"/>
-                  </a:schemeClr>
-                </a:solidFill>
-              </a:rPr>
-              <a:t> := new(</a:t>
-            </a:r>
+              <a:t>        stub = {</a:t>
+            </a:r>
+          </a:p>
+          <a:p>
+            <a:pPr/>
             <a:r>
               <a:rPr sz="1600" dirty="0" err="1">
                 <a:solidFill>
@@ -4485,46 +4342,11 @@
                   </a:schemeClr>
                 </a:solidFill>
               </a:rPr>
-              <a:t>mocks.ClientIdentity</a:t>
-            </a:r>
-            <a:r>
-              <a:rPr sz="1600" dirty="0">
-                <a:solidFill>
-                  <a:schemeClr val="bg1">
-                    <a:lumMod val="95000"/>
-                  </a:schemeClr>
-                </a:solidFill>
-              </a:rPr>
-              <a:t>)</a:t>
-            </a:r>
-            <a:br>
-              <a:rPr sz="1600" dirty="0">
-                <a:solidFill>
-                  <a:schemeClr val="bg1">
-                    <a:lumMod val="95000"/>
-                  </a:schemeClr>
-                </a:solidFill>
-              </a:rPr>
-            </a:br>
-            <a:br>
-              <a:rPr sz="1600" dirty="0">
-                <a:solidFill>
-                  <a:schemeClr val="bg1">
-                    <a:lumMod val="95000"/>
-                  </a:schemeClr>
-                </a:solidFill>
-              </a:rPr>
-            </a:br>
-            <a:r>
-              <a:rPr sz="1600" dirty="0">
-                <a:solidFill>
-                  <a:schemeClr val="bg1">
-                    <a:lumMod val="95000"/>
-                  </a:schemeClr>
-                </a:solidFill>
-              </a:rPr>
-              <a:t>    </a:t>
-            </a:r>
+              <a:t>            getState: sinon.stub(),</a:t>
+            </a:r>
+          </a:p>
+          <a:p>
+            <a:pPr/>
             <a:r>
               <a:rPr sz="1600" dirty="0" err="1">
                 <a:solidFill>
@@ -4533,18 +4355,11 @@
                   </a:schemeClr>
                 </a:solidFill>
               </a:rPr>
-              <a:t>mockCtx.On</a:t>
-            </a:r>
-            <a:r>
-              <a:rPr sz="1600" dirty="0">
-                <a:solidFill>
-                  <a:schemeClr val="bg1">
-                    <a:lumMod val="95000"/>
-                  </a:schemeClr>
-                </a:solidFill>
-              </a:rPr>
-              <a:t>("</a:t>
-            </a:r>
+              <a:t>            putState: sinon.stub(),</a:t>
+            </a:r>
+          </a:p>
+          <a:p>
+            <a:pPr/>
             <a:r>
               <a:rPr sz="1600" dirty="0" err="1">
                 <a:solidFill>
@@ -4553,18 +4368,11 @@
                   </a:schemeClr>
                 </a:solidFill>
               </a:rPr>
-              <a:t>GetStub</a:t>
-            </a:r>
-            <a:r>
-              <a:rPr sz="1600" dirty="0">
-                <a:solidFill>
-                  <a:schemeClr val="bg1">
-                    <a:lumMod val="95000"/>
-                  </a:schemeClr>
-                </a:solidFill>
-              </a:rPr>
-              <a:t>").Return(</a:t>
-            </a:r>
+              <a:t>        };</a:t>
+            </a:r>
+          </a:p>
+          <a:p>
+            <a:pPr/>
             <a:r>
               <a:rPr sz="1600" dirty="0" err="1">
                 <a:solidFill>
@@ -4573,37 +4381,11 @@
                   </a:schemeClr>
                 </a:solidFill>
               </a:rPr>
-              <a:t>mockStub</a:t>
-            </a:r>
-            <a:r>
-              <a:rPr sz="1600" dirty="0">
-                <a:solidFill>
-                  <a:schemeClr val="bg1">
-                    <a:lumMod val="95000"/>
-                  </a:schemeClr>
-                </a:solidFill>
-              </a:rPr>
-              <a:t>)</a:t>
-            </a:r>
-            <a:br>
-              <a:rPr sz="1600" dirty="0">
-                <a:solidFill>
-                  <a:schemeClr val="bg1">
-                    <a:lumMod val="95000"/>
-                  </a:schemeClr>
-                </a:solidFill>
-              </a:rPr>
-            </a:br>
-            <a:r>
-              <a:rPr sz="1600" dirty="0">
-                <a:solidFill>
-                  <a:schemeClr val="bg1">
-                    <a:lumMod val="95000"/>
-                  </a:schemeClr>
-                </a:solidFill>
-              </a:rPr>
-              <a:t>    </a:t>
-            </a:r>
+              <a:t>        identity = {</a:t>
+            </a:r>
+          </a:p>
+          <a:p>
+            <a:pPr/>
             <a:r>
               <a:rPr sz="1600" dirty="0" err="1">
                 <a:solidFill>
@@ -4612,18 +4394,11 @@
                   </a:schemeClr>
                 </a:solidFill>
               </a:rPr>
-              <a:t>mockCtx.On</a:t>
-            </a:r>
-            <a:r>
-              <a:rPr sz="1600" dirty="0">
-                <a:solidFill>
-                  <a:schemeClr val="bg1">
-                    <a:lumMod val="95000"/>
-                  </a:schemeClr>
-                </a:solidFill>
-              </a:rPr>
-              <a:t>("</a:t>
-            </a:r>
+              <a:t>            getMSPID: sinon.stub().returns('Org1MSP'),</a:t>
+            </a:r>
+          </a:p>
+          <a:p>
+            <a:pPr/>
             <a:r>
               <a:rPr sz="1600" dirty="0" err="1">
                 <a:solidFill>
@@ -4632,18 +4407,11 @@
                   </a:schemeClr>
                 </a:solidFill>
               </a:rPr>
-              <a:t>GetClientIdentity</a:t>
-            </a:r>
-            <a:r>
-              <a:rPr sz="1600" dirty="0">
-                <a:solidFill>
-                  <a:schemeClr val="bg1">
-                    <a:lumMod val="95000"/>
-                  </a:schemeClr>
-                </a:solidFill>
-              </a:rPr>
-              <a:t>").Return(</a:t>
-            </a:r>
+              <a:t>        };</a:t>
+            </a:r>
+          </a:p>
+          <a:p>
+            <a:pPr/>
             <a:r>
               <a:rPr sz="1600" dirty="0" err="1">
                 <a:solidFill>
@@ -4652,37 +4420,11 @@
                   </a:schemeClr>
                 </a:solidFill>
               </a:rPr>
-              <a:t>mockIdentity</a:t>
-            </a:r>
-            <a:r>
-              <a:rPr sz="1600" dirty="0">
-                <a:solidFill>
-                  <a:schemeClr val="bg1">
-                    <a:lumMod val="95000"/>
-                  </a:schemeClr>
-                </a:solidFill>
-              </a:rPr>
-              <a:t>)</a:t>
-            </a:r>
-            <a:br>
-              <a:rPr sz="1600" dirty="0">
-                <a:solidFill>
-                  <a:schemeClr val="bg1">
-                    <a:lumMod val="95000"/>
-                  </a:schemeClr>
-                </a:solidFill>
-              </a:rPr>
-            </a:br>
-            <a:r>
-              <a:rPr sz="1600" dirty="0">
-                <a:solidFill>
-                  <a:schemeClr val="bg1">
-                    <a:lumMod val="95000"/>
-                  </a:schemeClr>
-                </a:solidFill>
-              </a:rPr>
-              <a:t>    </a:t>
-            </a:r>
+              <a:t>        ctx = {</a:t>
+            </a:r>
+          </a:p>
+          <a:p>
+            <a:pPr/>
             <a:r>
               <a:rPr sz="1600" dirty="0" err="1">
                 <a:solidFill>
@@ -4691,18 +4433,11 @@
                   </a:schemeClr>
                 </a:solidFill>
               </a:rPr>
-              <a:t>mockIdentity.On</a:t>
-            </a:r>
-            <a:r>
-              <a:rPr sz="1600" dirty="0">
-                <a:solidFill>
-                  <a:schemeClr val="bg1">
-                    <a:lumMod val="95000"/>
-                  </a:schemeClr>
-                </a:solidFill>
-              </a:rPr>
-              <a:t>("</a:t>
-            </a:r>
+              <a:t>            stub,</a:t>
+            </a:r>
+          </a:p>
+          <a:p>
+            <a:pPr/>
             <a:r>
               <a:rPr sz="1600" dirty="0" err="1">
                 <a:solidFill>
@@ -4711,37 +4446,11 @@
                   </a:schemeClr>
                 </a:solidFill>
               </a:rPr>
-              <a:t>GetMSPID</a:t>
-            </a:r>
-            <a:r>
-              <a:rPr sz="1600" dirty="0">
-                <a:solidFill>
-                  <a:schemeClr val="bg1">
-                    <a:lumMod val="95000"/>
-                  </a:schemeClr>
-                </a:solidFill>
-              </a:rPr>
-              <a:t>").Return("Org1MSP", nil)</a:t>
-            </a:r>
-            <a:br>
-              <a:rPr sz="1600" dirty="0">
-                <a:solidFill>
-                  <a:schemeClr val="bg1">
-                    <a:lumMod val="95000"/>
-                  </a:schemeClr>
-                </a:solidFill>
-              </a:rPr>
-            </a:br>
-            <a:r>
-              <a:rPr sz="1600" dirty="0">
-                <a:solidFill>
-                  <a:schemeClr val="bg1">
-                    <a:lumMod val="95000"/>
-                  </a:schemeClr>
-                </a:solidFill>
-              </a:rPr>
-              <a:t>    </a:t>
-            </a:r>
+              <a:t>            clientIdentity: identity</a:t>
+            </a:r>
+          </a:p>
+          <a:p>
+            <a:pPr/>
             <a:r>
               <a:rPr sz="1600" dirty="0" err="1">
                 <a:solidFill>
@@ -4750,18 +4459,11 @@
                   </a:schemeClr>
                 </a:solidFill>
               </a:rPr>
-              <a:t>mockIdentity.On</a:t>
-            </a:r>
-            <a:r>
-              <a:rPr sz="1600" dirty="0">
-                <a:solidFill>
-                  <a:schemeClr val="bg1">
-                    <a:lumMod val="95000"/>
-                  </a:schemeClr>
-                </a:solidFill>
-              </a:rPr>
-              <a:t>("AssertAttributeValue", "role", "</a:t>
-            </a:r>
+              <a:t>        };</a:t>
+            </a:r>
+          </a:p>
+          <a:p>
+            <a:pPr/>
             <a:r>
               <a:rPr sz="1600" dirty="0" err="1">
                 <a:solidFill>
@@ -4770,53 +4472,8 @@
                   </a:schemeClr>
                 </a:solidFill>
               </a:rPr>
-              <a:t>registrador</a:t>
-            </a:r>
-            <a:r>
-              <a:rPr sz="1600" dirty="0">
-                <a:solidFill>
-                  <a:schemeClr val="bg1">
-                    <a:lumMod val="95000"/>
-                  </a:schemeClr>
-                </a:solidFill>
-              </a:rPr>
-              <a:t>").</a:t>
-            </a:r>
-            <a:br>
-              <a:rPr sz="1600" dirty="0">
-                <a:solidFill>
-                  <a:schemeClr val="bg1">
-                    <a:lumMod val="95000"/>
-                  </a:schemeClr>
-                </a:solidFill>
-              </a:rPr>
-            </a:br>
-            <a:r>
-              <a:rPr sz="1600" dirty="0">
-                <a:solidFill>
-                  <a:schemeClr val="bg1">
-                    <a:lumMod val="95000"/>
-                  </a:schemeClr>
-                </a:solidFill>
-              </a:rPr>
-              <a:t>        Return(nil)</a:t>
-            </a:r>
-            <a:br>
-              <a:rPr sz="1600" dirty="0">
-                <a:solidFill>
-                  <a:schemeClr val="bg1">
-                    <a:lumMod val="95000"/>
-                  </a:schemeClr>
-                </a:solidFill>
-              </a:rPr>
-            </a:br>
-            <a:endParaRPr sz="1600" dirty="0">
-              <a:solidFill>
-                <a:schemeClr val="bg1">
-                  <a:lumMod val="95000"/>
-                </a:schemeClr>
-              </a:solidFill>
-            </a:endParaRPr>
+              <a:t>    });</a:t>
+            </a:r>
           </a:p>
         </p:txBody>
       </p:sp>
@@ -4848,7 +4505,8 @@
           </a:bodyPr>
           <a:lstStyle/>
           <a:p>
-            <a:br>
+            <a:pPr/>
+            <a:r>
               <a:rPr lang="es-ES" sz="1600" dirty="0">
                 <a:solidFill>
                   <a:schemeClr val="bg1">
@@ -4856,7 +4514,11 @@
                   </a:schemeClr>
                 </a:solidFill>
               </a:rPr>
-            </a:br>
+              <a:t>    it('crea propiedad cuando no existe', async () =&gt; {</a:t>
+            </a:r>
+          </a:p>
+          <a:p>
+            <a:pPr/>
             <a:r>
               <a:rPr lang="es-ES" sz="1600" dirty="0">
                 <a:solidFill>
@@ -4865,18 +4527,11 @@
                   </a:schemeClr>
                 </a:solidFill>
               </a:rPr>
-              <a:t>    // </a:t>
-            </a:r>
-            <a:r>
-              <a:rPr lang="es-ES" sz="1600" dirty="0" err="1">
-                <a:solidFill>
-                  <a:schemeClr val="bg1">
-                    <a:lumMod val="95000"/>
-                  </a:schemeClr>
-                </a:solidFill>
-              </a:rPr>
-              <a:t>GetState</a:t>
-            </a:r>
+              <a:t>        // getState devuelve null (propiedad no existe)</a:t>
+            </a:r>
+          </a:p>
+          <a:p>
+            <a:pPr/>
             <a:r>
               <a:rPr lang="es-ES" sz="1600" dirty="0">
                 <a:solidFill>
@@ -4885,18 +4540,11 @@
                   </a:schemeClr>
                 </a:solidFill>
               </a:rPr>
-              <a:t> devuelve </a:t>
-            </a:r>
-            <a:r>
-              <a:rPr lang="es-ES" sz="1600" dirty="0" err="1">
-                <a:solidFill>
-                  <a:schemeClr val="bg1">
-                    <a:lumMod val="95000"/>
-                  </a:schemeClr>
-                </a:solidFill>
-              </a:rPr>
-              <a:t>nil</a:t>
-            </a:r>
+              <a:t>        stub.getState.resolves(null);</a:t>
+            </a:r>
+          </a:p>
+          <a:p>
+            <a:pPr/>
             <a:r>
               <a:rPr lang="es-ES" sz="1600" dirty="0">
                 <a:solidFill>
@@ -4905,9 +4553,12 @@
                   </a:schemeClr>
                 </a:solidFill>
               </a:rPr>
-              <a:t> (propiedad no existe)</a:t>
-            </a:r>
-            <a:br>
+              <a:t>        // putState acepta cualquier valor</a:t>
+            </a:r>
+          </a:p>
+          <a:p>
+            <a:pPr/>
+            <a:r>
               <a:rPr lang="es-ES" sz="1600" dirty="0">
                 <a:solidFill>
                   <a:schemeClr val="bg1">
@@ -4915,7 +4566,11 @@
                   </a:schemeClr>
                 </a:solidFill>
               </a:rPr>
-            </a:br>
+              <a:t>        stub.putState.resolves();</a:t>
+            </a:r>
+          </a:p>
+          <a:p>
+            <a:pPr/>
             <a:r>
               <a:rPr lang="es-ES" sz="1600" dirty="0">
                 <a:solidFill>
@@ -4924,18 +4579,11 @@
                   </a:schemeClr>
                 </a:solidFill>
               </a:rPr>
-              <a:t>    </a:t>
-            </a:r>
-            <a:r>
-              <a:rPr lang="es-ES" sz="1600" dirty="0" err="1">
-                <a:solidFill>
-                  <a:schemeClr val="bg1">
-                    <a:lumMod val="95000"/>
-                  </a:schemeClr>
-                </a:solidFill>
-              </a:rPr>
-              <a:t>mockStub.On</a:t>
-            </a:r>
+              <a:t/>
+            </a:r>
+          </a:p>
+          <a:p>
+            <a:pPr/>
             <a:r>
               <a:rPr lang="es-ES" sz="1600" dirty="0">
                 <a:solidFill>
@@ -4944,18 +4592,11 @@
                   </a:schemeClr>
                 </a:solidFill>
               </a:rPr>
-              <a:t>("</a:t>
-            </a:r>
-            <a:r>
-              <a:rPr lang="es-ES" sz="1600" dirty="0" err="1">
-                <a:solidFill>
-                  <a:schemeClr val="bg1">
-                    <a:lumMod val="95000"/>
-                  </a:schemeClr>
-                </a:solidFill>
-              </a:rPr>
-              <a:t>GetState</a:t>
-            </a:r>
+              <a:t>        // Ejecutar</a:t>
+            </a:r>
+          </a:p>
+          <a:p>
+            <a:pPr/>
             <a:r>
               <a:rPr lang="es-ES" sz="1600" dirty="0">
                 <a:solidFill>
@@ -4964,18 +4605,11 @@
                   </a:schemeClr>
                 </a:solidFill>
               </a:rPr>
-              <a:t>", "PROP001").</a:t>
-            </a:r>
-            <a:r>
-              <a:rPr lang="es-ES" sz="1600" dirty="0" err="1">
-                <a:solidFill>
-                  <a:schemeClr val="bg1">
-                    <a:lumMod val="95000"/>
-                  </a:schemeClr>
-                </a:solidFill>
-              </a:rPr>
-              <a:t>Return</a:t>
-            </a:r>
+              <a:t>        const contract = new SmartContract();</a:t>
+            </a:r>
+          </a:p>
+          <a:p>
+            <a:pPr/>
             <a:r>
               <a:rPr lang="es-ES" sz="1600" dirty="0">
                 <a:solidFill>
@@ -4984,18 +4618,11 @@
                   </a:schemeClr>
                 </a:solidFill>
               </a:rPr>
-              <a:t>(</a:t>
-            </a:r>
-            <a:r>
-              <a:rPr lang="es-ES" sz="1600" dirty="0" err="1">
-                <a:solidFill>
-                  <a:schemeClr val="bg1">
-                    <a:lumMod val="95000"/>
-                  </a:schemeClr>
-                </a:solidFill>
-              </a:rPr>
-              <a:t>nil</a:t>
-            </a:r>
+              <a:t>        await contract.CreateProperty(ctx,</a:t>
+            </a:r>
+          </a:p>
+          <a:p>
+            <a:pPr/>
             <a:r>
               <a:rPr lang="es-ES" sz="1600" dirty="0">
                 <a:solidFill>
@@ -5004,18 +4631,11 @@
                   </a:schemeClr>
                 </a:solidFill>
               </a:rPr>
-              <a:t>, </a:t>
-            </a:r>
-            <a:r>
-              <a:rPr lang="es-ES" sz="1600" dirty="0" err="1">
-                <a:solidFill>
-                  <a:schemeClr val="bg1">
-                    <a:lumMod val="95000"/>
-                  </a:schemeClr>
-                </a:solidFill>
-              </a:rPr>
-              <a:t>nil</a:t>
-            </a:r>
+              <a:t>            'PROP001', 'Calle Mayor 1', 'Org1MSP',</a:t>
+            </a:r>
+          </a:p>
+          <a:p>
+            <a:pPr/>
             <a:r>
               <a:rPr lang="es-ES" sz="1600" dirty="0">
                 <a:solidFill>
@@ -5024,9 +4644,12 @@
                   </a:schemeClr>
                 </a:solidFill>
               </a:rPr>
-              <a:t>)</a:t>
-            </a:r>
-            <a:br>
+              <a:t>            120, 'apartment', 250000);</a:t>
+            </a:r>
+          </a:p>
+          <a:p>
+            <a:pPr/>
+            <a:r>
               <a:rPr lang="es-ES" sz="1600" dirty="0">
                 <a:solidFill>
                   <a:schemeClr val="bg1">
@@ -5034,7 +4657,11 @@
                   </a:schemeClr>
                 </a:solidFill>
               </a:rPr>
-            </a:br>
+              <a:t/>
+            </a:r>
+          </a:p>
+          <a:p>
+            <a:pPr/>
             <a:r>
               <a:rPr lang="es-ES" sz="1600" dirty="0">
                 <a:solidFill>
@@ -5043,18 +4670,11 @@
                   </a:schemeClr>
                 </a:solidFill>
               </a:rPr>
-              <a:t>    // </a:t>
-            </a:r>
-            <a:r>
-              <a:rPr lang="es-ES" sz="1600" dirty="0" err="1">
-                <a:solidFill>
-                  <a:schemeClr val="bg1">
-                    <a:lumMod val="95000"/>
-                  </a:schemeClr>
-                </a:solidFill>
-              </a:rPr>
-              <a:t>PutState</a:t>
-            </a:r>
+              <a:t>        // Verificar</a:t>
+            </a:r>
+          </a:p>
+          <a:p>
+            <a:pPr/>
             <a:r>
               <a:rPr lang="es-ES" sz="1600" dirty="0">
                 <a:solidFill>
@@ -5063,9 +4683,12 @@
                   </a:schemeClr>
                 </a:solidFill>
               </a:rPr>
-              <a:t> acepta cualquier valor</a:t>
-            </a:r>
-            <a:br>
+              <a:t>        expect(stub.putState.calledOnce).to.be.true;</a:t>
+            </a:r>
+          </a:p>
+          <a:p>
+            <a:pPr/>
+            <a:r>
               <a:rPr lang="es-ES" sz="1600" dirty="0">
                 <a:solidFill>
                   <a:schemeClr val="bg1">
@@ -5073,7 +4696,11 @@
                   </a:schemeClr>
                 </a:solidFill>
               </a:rPr>
-            </a:br>
+              <a:t>    });</a:t>
+            </a:r>
+          </a:p>
+          <a:p>
+            <a:pPr/>
             <a:r>
               <a:rPr lang="es-ES" sz="1600" dirty="0">
                 <a:solidFill>
@@ -5082,499 +4709,8 @@
                   </a:schemeClr>
                 </a:solidFill>
               </a:rPr>
-              <a:t>    </a:t>
-            </a:r>
-            <a:r>
-              <a:rPr lang="es-ES" sz="1600" dirty="0" err="1">
-                <a:solidFill>
-                  <a:schemeClr val="bg1">
-                    <a:lumMod val="95000"/>
-                  </a:schemeClr>
-                </a:solidFill>
-              </a:rPr>
-              <a:t>mockStub.On</a:t>
-            </a:r>
-            <a:r>
-              <a:rPr lang="es-ES" sz="1600" dirty="0">
-                <a:solidFill>
-                  <a:schemeClr val="bg1">
-                    <a:lumMod val="95000"/>
-                  </a:schemeClr>
-                </a:solidFill>
-              </a:rPr>
-              <a:t>("</a:t>
-            </a:r>
-            <a:r>
-              <a:rPr lang="es-ES" sz="1600" dirty="0" err="1">
-                <a:solidFill>
-                  <a:schemeClr val="bg1">
-                    <a:lumMod val="95000"/>
-                  </a:schemeClr>
-                </a:solidFill>
-              </a:rPr>
-              <a:t>PutState</a:t>
-            </a:r>
-            <a:r>
-              <a:rPr lang="es-ES" sz="1600" dirty="0">
-                <a:solidFill>
-                  <a:schemeClr val="bg1">
-                    <a:lumMod val="95000"/>
-                  </a:schemeClr>
-                </a:solidFill>
-              </a:rPr>
-              <a:t>", "PROP001", </a:t>
-            </a:r>
-            <a:r>
-              <a:rPr lang="es-ES" sz="1600" dirty="0" err="1">
-                <a:solidFill>
-                  <a:schemeClr val="bg1">
-                    <a:lumMod val="95000"/>
-                  </a:schemeClr>
-                </a:solidFill>
-              </a:rPr>
-              <a:t>mock.Anything</a:t>
-            </a:r>
-            <a:r>
-              <a:rPr lang="es-ES" sz="1600" dirty="0">
-                <a:solidFill>
-                  <a:schemeClr val="bg1">
-                    <a:lumMod val="95000"/>
-                  </a:schemeClr>
-                </a:solidFill>
-              </a:rPr>
-              <a:t>).</a:t>
-            </a:r>
-            <a:r>
-              <a:rPr lang="es-ES" sz="1600" dirty="0" err="1">
-                <a:solidFill>
-                  <a:schemeClr val="bg1">
-                    <a:lumMod val="95000"/>
-                  </a:schemeClr>
-                </a:solidFill>
-              </a:rPr>
-              <a:t>Return</a:t>
-            </a:r>
-            <a:r>
-              <a:rPr lang="es-ES" sz="1600" dirty="0">
-                <a:solidFill>
-                  <a:schemeClr val="bg1">
-                    <a:lumMod val="95000"/>
-                  </a:schemeClr>
-                </a:solidFill>
-              </a:rPr>
-              <a:t>(</a:t>
-            </a:r>
-            <a:r>
-              <a:rPr lang="es-ES" sz="1600" dirty="0" err="1">
-                <a:solidFill>
-                  <a:schemeClr val="bg1">
-                    <a:lumMod val="95000"/>
-                  </a:schemeClr>
-                </a:solidFill>
-              </a:rPr>
-              <a:t>nil</a:t>
-            </a:r>
-            <a:r>
-              <a:rPr lang="es-ES" sz="1600" dirty="0">
-                <a:solidFill>
-                  <a:schemeClr val="bg1">
-                    <a:lumMod val="95000"/>
-                  </a:schemeClr>
-                </a:solidFill>
-              </a:rPr>
-              <a:t>)</a:t>
-            </a:r>
-            <a:br>
-              <a:rPr lang="es-ES" sz="1600" dirty="0">
-                <a:solidFill>
-                  <a:schemeClr val="bg1">
-                    <a:lumMod val="95000"/>
-                  </a:schemeClr>
-                </a:solidFill>
-              </a:rPr>
-            </a:br>
-            <a:br>
-              <a:rPr lang="es-ES" sz="1600" dirty="0">
-                <a:solidFill>
-                  <a:schemeClr val="bg1">
-                    <a:lumMod val="95000"/>
-                  </a:schemeClr>
-                </a:solidFill>
-              </a:rPr>
-            </a:br>
-            <a:r>
-              <a:rPr lang="es-ES" sz="1600" dirty="0">
-                <a:solidFill>
-                  <a:schemeClr val="bg1">
-                    <a:lumMod val="95000"/>
-                  </a:schemeClr>
-                </a:solidFill>
-              </a:rPr>
-              <a:t>    // Ejecutar</a:t>
-            </a:r>
-            <a:br>
-              <a:rPr lang="es-ES" sz="1600" dirty="0">
-                <a:solidFill>
-                  <a:schemeClr val="bg1">
-                    <a:lumMod val="95000"/>
-                  </a:schemeClr>
-                </a:solidFill>
-              </a:rPr>
-            </a:br>
-            <a:r>
-              <a:rPr lang="es-ES" sz="1600" dirty="0">
-                <a:solidFill>
-                  <a:schemeClr val="bg1">
-                    <a:lumMod val="95000"/>
-                  </a:schemeClr>
-                </a:solidFill>
-              </a:rPr>
-              <a:t>    </a:t>
-            </a:r>
-            <a:r>
-              <a:rPr lang="es-ES" sz="1600" dirty="0" err="1">
-                <a:solidFill>
-                  <a:schemeClr val="bg1">
-                    <a:lumMod val="95000"/>
-                  </a:schemeClr>
-                </a:solidFill>
-              </a:rPr>
-              <a:t>contract</a:t>
-            </a:r>
-            <a:r>
-              <a:rPr lang="es-ES" sz="1600" dirty="0">
-                <a:solidFill>
-                  <a:schemeClr val="bg1">
-                    <a:lumMod val="95000"/>
-                  </a:schemeClr>
-                </a:solidFill>
-              </a:rPr>
-              <a:t> := </a:t>
-            </a:r>
-            <a:r>
-              <a:rPr lang="es-ES" sz="1600" dirty="0" err="1">
-                <a:solidFill>
-                  <a:schemeClr val="bg1">
-                    <a:lumMod val="95000"/>
-                  </a:schemeClr>
-                </a:solidFill>
-              </a:rPr>
-              <a:t>SmartContract</a:t>
-            </a:r>
-            <a:r>
-              <a:rPr lang="es-ES" sz="1600" dirty="0">
-                <a:solidFill>
-                  <a:schemeClr val="bg1">
-                    <a:lumMod val="95000"/>
-                  </a:schemeClr>
-                </a:solidFill>
-              </a:rPr>
-              <a:t>{}</a:t>
-            </a:r>
-            <a:br>
-              <a:rPr lang="es-ES" sz="1600" dirty="0">
-                <a:solidFill>
-                  <a:schemeClr val="bg1">
-                    <a:lumMod val="95000"/>
-                  </a:schemeClr>
-                </a:solidFill>
-              </a:rPr>
-            </a:br>
-            <a:r>
-              <a:rPr lang="es-ES" sz="1600" dirty="0">
-                <a:solidFill>
-                  <a:schemeClr val="bg1">
-                    <a:lumMod val="95000"/>
-                  </a:schemeClr>
-                </a:solidFill>
-              </a:rPr>
-              <a:t>    </a:t>
-            </a:r>
-            <a:r>
-              <a:rPr lang="es-ES" sz="1600" dirty="0" err="1">
-                <a:solidFill>
-                  <a:schemeClr val="bg1">
-                    <a:lumMod val="95000"/>
-                  </a:schemeClr>
-                </a:solidFill>
-              </a:rPr>
-              <a:t>err</a:t>
-            </a:r>
-            <a:r>
-              <a:rPr lang="es-ES" sz="1600" dirty="0">
-                <a:solidFill>
-                  <a:schemeClr val="bg1">
-                    <a:lumMod val="95000"/>
-                  </a:schemeClr>
-                </a:solidFill>
-              </a:rPr>
-              <a:t> := </a:t>
-            </a:r>
-            <a:r>
-              <a:rPr lang="es-ES" sz="1600" dirty="0" err="1">
-                <a:solidFill>
-                  <a:schemeClr val="bg1">
-                    <a:lumMod val="95000"/>
-                  </a:schemeClr>
-                </a:solidFill>
-              </a:rPr>
-              <a:t>contract.CreateProperty</a:t>
-            </a:r>
-            <a:r>
-              <a:rPr lang="es-ES" sz="1600" dirty="0">
-                <a:solidFill>
-                  <a:schemeClr val="bg1">
-                    <a:lumMod val="95000"/>
-                  </a:schemeClr>
-                </a:solidFill>
-              </a:rPr>
-              <a:t>(</a:t>
-            </a:r>
-            <a:r>
-              <a:rPr lang="es-ES" sz="1600" dirty="0" err="1">
-                <a:solidFill>
-                  <a:schemeClr val="bg1">
-                    <a:lumMod val="95000"/>
-                  </a:schemeClr>
-                </a:solidFill>
-              </a:rPr>
-              <a:t>mockCtx</a:t>
-            </a:r>
-            <a:r>
-              <a:rPr lang="es-ES" sz="1600" dirty="0">
-                <a:solidFill>
-                  <a:schemeClr val="bg1">
-                    <a:lumMod val="95000"/>
-                  </a:schemeClr>
-                </a:solidFill>
-              </a:rPr>
-              <a:t>,</a:t>
-            </a:r>
-            <a:br>
-              <a:rPr lang="es-ES" sz="1600" dirty="0">
-                <a:solidFill>
-                  <a:schemeClr val="bg1">
-                    <a:lumMod val="95000"/>
-                  </a:schemeClr>
-                </a:solidFill>
-              </a:rPr>
-            </a:br>
-            <a:r>
-              <a:rPr lang="es-ES" sz="1600" dirty="0">
-                <a:solidFill>
-                  <a:schemeClr val="bg1">
-                    <a:lumMod val="95000"/>
-                  </a:schemeClr>
-                </a:solidFill>
-              </a:rPr>
-              <a:t>        "PROP001", "Calle Mayor 1", "Org1MSP", 120, "</a:t>
-            </a:r>
-            <a:r>
-              <a:rPr lang="es-ES" sz="1600" dirty="0" err="1">
-                <a:solidFill>
-                  <a:schemeClr val="bg1">
-                    <a:lumMod val="95000"/>
-                  </a:schemeClr>
-                </a:solidFill>
-              </a:rPr>
-              <a:t>apartment</a:t>
-            </a:r>
-            <a:r>
-              <a:rPr lang="es-ES" sz="1600" dirty="0">
-                <a:solidFill>
-                  <a:schemeClr val="bg1">
-                    <a:lumMod val="95000"/>
-                  </a:schemeClr>
-                </a:solidFill>
-              </a:rPr>
-              <a:t>", 250000)</a:t>
-            </a:r>
-            <a:br>
-              <a:rPr lang="es-ES" sz="1600" dirty="0">
-                <a:solidFill>
-                  <a:schemeClr val="bg1">
-                    <a:lumMod val="95000"/>
-                  </a:schemeClr>
-                </a:solidFill>
-              </a:rPr>
-            </a:br>
-            <a:br>
-              <a:rPr lang="es-ES" sz="1600" dirty="0">
-                <a:solidFill>
-                  <a:schemeClr val="bg1">
-                    <a:lumMod val="95000"/>
-                  </a:schemeClr>
-                </a:solidFill>
-              </a:rPr>
-            </a:br>
-            <a:r>
-              <a:rPr lang="es-ES" sz="1600" dirty="0">
-                <a:solidFill>
-                  <a:schemeClr val="bg1">
-                    <a:lumMod val="95000"/>
-                  </a:schemeClr>
-                </a:solidFill>
-              </a:rPr>
-              <a:t>    // Verificar</a:t>
-            </a:r>
-            <a:br>
-              <a:rPr lang="es-ES" sz="1600" dirty="0">
-                <a:solidFill>
-                  <a:schemeClr val="bg1">
-                    <a:lumMod val="95000"/>
-                  </a:schemeClr>
-                </a:solidFill>
-              </a:rPr>
-            </a:br>
-            <a:r>
-              <a:rPr lang="es-ES" sz="1600" dirty="0">
-                <a:solidFill>
-                  <a:schemeClr val="bg1">
-                    <a:lumMod val="95000"/>
-                  </a:schemeClr>
-                </a:solidFill>
-              </a:rPr>
-              <a:t>    </a:t>
-            </a:r>
-            <a:r>
-              <a:rPr lang="es-ES" sz="1600" dirty="0" err="1">
-                <a:solidFill>
-                  <a:schemeClr val="bg1">
-                    <a:lumMod val="95000"/>
-                  </a:schemeClr>
-                </a:solidFill>
-              </a:rPr>
-              <a:t>assert.NoError</a:t>
-            </a:r>
-            <a:r>
-              <a:rPr lang="es-ES" sz="1600" dirty="0">
-                <a:solidFill>
-                  <a:schemeClr val="bg1">
-                    <a:lumMod val="95000"/>
-                  </a:schemeClr>
-                </a:solidFill>
-              </a:rPr>
-              <a:t>(t, </a:t>
-            </a:r>
-            <a:r>
-              <a:rPr lang="es-ES" sz="1600" dirty="0" err="1">
-                <a:solidFill>
-                  <a:schemeClr val="bg1">
-                    <a:lumMod val="95000"/>
-                  </a:schemeClr>
-                </a:solidFill>
-              </a:rPr>
-              <a:t>err</a:t>
-            </a:r>
-            <a:r>
-              <a:rPr lang="es-ES" sz="1600" dirty="0">
-                <a:solidFill>
-                  <a:schemeClr val="bg1">
-                    <a:lumMod val="95000"/>
-                  </a:schemeClr>
-                </a:solidFill>
-              </a:rPr>
-              <a:t>)</a:t>
-            </a:r>
-            <a:br>
-              <a:rPr lang="es-ES" sz="1600" dirty="0">
-                <a:solidFill>
-                  <a:schemeClr val="bg1">
-                    <a:lumMod val="95000"/>
-                  </a:schemeClr>
-                </a:solidFill>
-              </a:rPr>
-            </a:br>
-            <a:r>
-              <a:rPr lang="es-ES" sz="1600" dirty="0">
-                <a:solidFill>
-                  <a:schemeClr val="bg1">
-                    <a:lumMod val="95000"/>
-                  </a:schemeClr>
-                </a:solidFill>
-              </a:rPr>
-              <a:t>    </a:t>
-            </a:r>
-            <a:r>
-              <a:rPr lang="es-ES" sz="1600" dirty="0" err="1">
-                <a:solidFill>
-                  <a:schemeClr val="bg1">
-                    <a:lumMod val="95000"/>
-                  </a:schemeClr>
-                </a:solidFill>
-              </a:rPr>
-              <a:t>mockStub.AssertCalled</a:t>
-            </a:r>
-            <a:r>
-              <a:rPr lang="es-ES" sz="1600" dirty="0">
-                <a:solidFill>
-                  <a:schemeClr val="bg1">
-                    <a:lumMod val="95000"/>
-                  </a:schemeClr>
-                </a:solidFill>
-              </a:rPr>
-              <a:t>(t, "</a:t>
-            </a:r>
-            <a:r>
-              <a:rPr lang="es-ES" sz="1600" dirty="0" err="1">
-                <a:solidFill>
-                  <a:schemeClr val="bg1">
-                    <a:lumMod val="95000"/>
-                  </a:schemeClr>
-                </a:solidFill>
-              </a:rPr>
-              <a:t>PutState</a:t>
-            </a:r>
-            <a:r>
-              <a:rPr lang="es-ES" sz="1600" dirty="0">
-                <a:solidFill>
-                  <a:schemeClr val="bg1">
-                    <a:lumMod val="95000"/>
-                  </a:schemeClr>
-                </a:solidFill>
-              </a:rPr>
-              <a:t>", "PROP001", </a:t>
-            </a:r>
-            <a:r>
-              <a:rPr lang="es-ES" sz="1600" dirty="0" err="1">
-                <a:solidFill>
-                  <a:schemeClr val="bg1">
-                    <a:lumMod val="95000"/>
-                  </a:schemeClr>
-                </a:solidFill>
-              </a:rPr>
-              <a:t>mock.Anything</a:t>
-            </a:r>
-            <a:r>
-              <a:rPr lang="es-ES" sz="1600" dirty="0">
-                <a:solidFill>
-                  <a:schemeClr val="bg1">
-                    <a:lumMod val="95000"/>
-                  </a:schemeClr>
-                </a:solidFill>
-              </a:rPr>
-              <a:t>)</a:t>
-            </a:r>
-            <a:br>
-              <a:rPr lang="es-ES" sz="1600" dirty="0">
-                <a:solidFill>
-                  <a:schemeClr val="bg1">
-                    <a:lumMod val="95000"/>
-                  </a:schemeClr>
-                </a:solidFill>
-              </a:rPr>
-            </a:br>
-            <a:r>
-              <a:rPr lang="es-ES" sz="1600" dirty="0">
-                <a:solidFill>
-                  <a:schemeClr val="bg1">
-                    <a:lumMod val="95000"/>
-                  </a:schemeClr>
-                </a:solidFill>
-              </a:rPr>
-              <a:t>}</a:t>
-            </a:r>
-            <a:endParaRPr lang="es-ES" sz="1600" dirty="0"/>
+              <a:t>});</a:t>
+            </a:r>
           </a:p>
         </p:txBody>
       </p:sp>
@@ -10494,6 +9630,1738 @@
 </p:sld>
 </file>
 
+<file path=ppt/slides/slide23.xml><?xml version="1.0" encoding="utf-8"?>
+<p:sld xmlns:a="http://schemas.openxmlformats.org/drawingml/2006/main" xmlns:p="http://schemas.openxmlformats.org/presentationml/2006/main" xmlns:r="http://schemas.openxmlformats.org/officeDocument/2006/relationships">
+  <p:cSld>
+    <p:spTree>
+      <p:nvGrpSpPr>
+        <p:cNvPr id="1" name=""/>
+        <p:cNvGrpSpPr/>
+        <p:nvPr/>
+      </p:nvGrpSpPr>
+      <p:grpSpPr/>
+      <p:sp>
+        <p:nvSpPr>
+          <p:cNvPr id="2" name="Rectangle 1"/>
+          <p:cNvSpPr/>
+          <p:nvPr/>
+        </p:nvSpPr>
+        <p:spPr>
+          <a:xfrm>
+            <a:off x="0" y="0"/>
+            <a:ext cx="12188952" cy="73152"/>
+          </a:xfrm>
+          <a:prstGeom prst="rect">
+            <a:avLst/>
+          </a:prstGeom>
+          <a:solidFill>
+            <a:srgbClr val="22627E"/>
+          </a:solidFill>
+          <a:ln>
+            <a:noFill/>
+          </a:ln>
+        </p:spPr>
+        <p:style>
+          <a:lnRef idx="1">
+            <a:schemeClr val="accent1"/>
+          </a:lnRef>
+          <a:fillRef idx="3">
+            <a:schemeClr val="accent1"/>
+          </a:fillRef>
+          <a:effectRef idx="2">
+            <a:schemeClr val="accent1"/>
+          </a:effectRef>
+          <a:fontRef idx="minor">
+            <a:schemeClr val="lt1"/>
+          </a:fontRef>
+        </p:style>
+        <p:txBody>
+          <a:bodyPr rtlCol="0" anchor="ctr"/>
+          <a:lstStyle/>
+          <a:p>
+            <a:pPr algn="ctr"/>
+          </a:p>
+        </p:txBody>
+      </p:sp>
+      <p:sp>
+        <p:nvSpPr>
+          <p:cNvPr id="3" name="TextBox 2"/>
+          <p:cNvSpPr txBox="1"/>
+          <p:nvPr/>
+        </p:nvSpPr>
+        <p:spPr>
+          <a:xfrm>
+            <a:off x="457200" y="274320"/>
+            <a:ext cx="10972800" cy="731520"/>
+          </a:xfrm>
+          <a:prstGeom prst="rect">
+            <a:avLst/>
+          </a:prstGeom>
+          <a:noFill/>
+        </p:spPr>
+        <p:txBody>
+          <a:bodyPr wrap="square"/>
+          <a:lstStyle/>
+          <a:p>
+            <a:pPr algn="l">
+              <a:defRPr sz="3200" b="1">
+                <a:solidFill>
+                  <a:srgbClr val="22627E"/>
+                </a:solidFill>
+                <a:latin typeface="Calibri"/>
+              </a:defRPr>
+            </a:pPr>
+            <a:r>
+              <a:t>Respuestas al debate (1/2)</a:t>
+            </a:r>
+          </a:p>
+        </p:txBody>
+      </p:sp>
+      <p:sp>
+        <p:nvSpPr>
+          <p:cNvPr id="4" name="Rectangle 3"/>
+          <p:cNvSpPr/>
+          <p:nvPr/>
+        </p:nvSpPr>
+        <p:spPr>
+          <a:xfrm>
+            <a:off x="457200" y="1051560"/>
+            <a:ext cx="10972800" cy="27432"/>
+          </a:xfrm>
+          <a:prstGeom prst="rect">
+            <a:avLst/>
+          </a:prstGeom>
+          <a:solidFill>
+            <a:srgbClr val="22627E"/>
+          </a:solidFill>
+          <a:ln>
+            <a:noFill/>
+          </a:ln>
+        </p:spPr>
+        <p:style>
+          <a:lnRef idx="1">
+            <a:schemeClr val="accent1"/>
+          </a:lnRef>
+          <a:fillRef idx="3">
+            <a:schemeClr val="accent1"/>
+          </a:fillRef>
+          <a:effectRef idx="2">
+            <a:schemeClr val="accent1"/>
+          </a:effectRef>
+          <a:fontRef idx="minor">
+            <a:schemeClr val="lt1"/>
+          </a:fontRef>
+        </p:style>
+        <p:txBody>
+          <a:bodyPr rtlCol="0" anchor="ctr"/>
+          <a:lstStyle/>
+          <a:p>
+            <a:pPr algn="ctr"/>
+          </a:p>
+        </p:txBody>
+      </p:sp>
+      <p:sp>
+        <p:nvSpPr>
+          <p:cNvPr id="5" name="TextBox 4"/>
+          <p:cNvSpPr txBox="1"/>
+          <p:nvPr/>
+        </p:nvSpPr>
+        <p:spPr>
+          <a:xfrm>
+            <a:off x="640080" y="1280160"/>
+            <a:ext cx="10515600" cy="5029200"/>
+          </a:xfrm>
+          <a:prstGeom prst="rect">
+            <a:avLst/>
+          </a:prstGeom>
+          <a:noFill/>
+        </p:spPr>
+        <p:txBody>
+          <a:bodyPr wrap="square">
+            <a:spAutoFit/>
+          </a:bodyPr>
+          <a:lstStyle/>
+          <a:p>
+            <a:pPr>
+              <a:spcAft>
+                <a:spcPts val="800"/>
+              </a:spcAft>
+              <a:defRPr sz="2000">
+                <a:solidFill>
+                  <a:srgbClr val="333333"/>
+                </a:solidFill>
+                <a:latin typeface="Calibri"/>
+              </a:defRPr>
+            </a:pPr>
+            <a:r>
+              <a:t>1. Lo mas complejo / lo mas util del modulo:</a:t>
+            </a:r>
+          </a:p>
+          <a:p>
+            <a:pPr lvl="1">
+              <a:spcAft>
+                <a:spcPts val="400"/>
+              </a:spcAft>
+              <a:defRPr sz="1700">
+                <a:solidFill>
+                  <a:srgbClr val="666666"/>
+                </a:solidFill>
+                <a:latin typeface="Calibri"/>
+              </a:defRPr>
+            </a:pPr>
+            <a:r>
+              <a:t>    Complejo: el lifecycle de chaincodes (4 pasos) y el determinismo (errores silenciosos).</a:t>
+            </a:r>
+          </a:p>
+          <a:p>
+            <a:pPr lvl="1">
+              <a:spcAft>
+                <a:spcPts val="400"/>
+              </a:spcAft>
+              <a:defRPr sz="1700">
+                <a:solidFill>
+                  <a:srgbClr val="666666"/>
+                </a:solidFill>
+                <a:latin typeface="Calibri"/>
+              </a:defRPr>
+            </a:pPr>
+            <a:r>
+              <a:t>    Util: la capacidad de razonar sobre permisos antes de tocar codigo (MSPID/ABAC).</a:t>
+            </a:r>
+          </a:p>
+          <a:p>
+            <a:pPr lvl="1">
+              <a:spcAft>
+                <a:spcPts val="400"/>
+              </a:spcAft>
+              <a:defRPr sz="1700">
+                <a:solidFill>
+                  <a:srgbClr val="666666"/>
+                </a:solidFill>
+                <a:latin typeface="Calibri"/>
+              </a:defRPr>
+            </a:pPr>
+            <a:r>
+              <a:t>    No hay respuesta unica — depende del background (EVM vs Fabric).</a:t>
+            </a:r>
+          </a:p>
+          <a:p>
+            <a:pPr lvl="1">
+              <a:spcAft>
+                <a:spcPts val="400"/>
+              </a:spcAft>
+              <a:defRPr sz="1700">
+                <a:solidFill>
+                  <a:srgbClr val="666666"/>
+                </a:solidFill>
+                <a:latin typeface="Calibri"/>
+              </a:defRPr>
+            </a:pPr>
+            <a:r>
+              <a:t>    La mayoria coincide: los conceptos son simples, la operacion es donde esta la dificultad.</a:t>
+            </a:r>
+          </a:p>
+          <a:p>
+            <a:pPr>
+              <a:spcAft>
+                <a:spcPts val="800"/>
+              </a:spcAft>
+              <a:defRPr sz="2000">
+                <a:solidFill>
+                  <a:srgbClr val="333333"/>
+                </a:solidFill>
+                <a:latin typeface="Calibri"/>
+              </a:defRPr>
+            </a:pPr>
+            <a:r>
+              <a:t>2. Aplicacion real en vuestro sector:</a:t>
+            </a:r>
+          </a:p>
+          <a:p>
+            <a:pPr lvl="1">
+              <a:spcAft>
+                <a:spcPts val="400"/>
+              </a:spcAft>
+              <a:defRPr sz="1700">
+                <a:solidFill>
+                  <a:srgbClr val="666666"/>
+                </a:solidFill>
+                <a:latin typeface="Calibri"/>
+              </a:defRPr>
+            </a:pPr>
+            <a:r>
+              <a:t>    Depende del sector: trazabilidad, KYC compartido, tokenizacion B2B, registros regulados.</a:t>
+            </a:r>
+          </a:p>
+          <a:p>
+            <a:pPr lvl="1">
+              <a:spcAft>
+                <a:spcPts val="400"/>
+              </a:spcAft>
+              <a:defRPr sz="1700">
+                <a:solidFill>
+                  <a:srgbClr val="666666"/>
+                </a:solidFill>
+                <a:latin typeface="Calibri"/>
+              </a:defRPr>
+            </a:pPr>
+            <a:r>
+              <a:t>    Regla de oro: hay multiples orgs con desconfianza mutua + necesidad de auditoria.</a:t>
+            </a:r>
+          </a:p>
+          <a:p>
+            <a:pPr lvl="1">
+              <a:spcAft>
+                <a:spcPts val="400"/>
+              </a:spcAft>
+              <a:defRPr sz="1700">
+                <a:solidFill>
+                  <a:srgbClr val="666666"/>
+                </a:solidFill>
+                <a:latin typeface="Calibri"/>
+              </a:defRPr>
+            </a:pPr>
+            <a:r>
+              <a:t>    Si un solo actor es suficiente, una base de datos normal es mejor opcion.</a:t>
+            </a:r>
+          </a:p>
+          <a:p>
+            <a:pPr>
+              <a:spcAft>
+                <a:spcPts val="800"/>
+              </a:spcAft>
+              <a:defRPr sz="2000">
+                <a:solidFill>
+                  <a:srgbClr val="333333"/>
+                </a:solidFill>
+                <a:latin typeface="Calibri"/>
+              </a:defRPr>
+            </a:pPr>
+            <a:r>
+              <a:t>3. ¿Que echais en falta en Fabric vs Ethereum (y al reves)?</a:t>
+            </a:r>
+          </a:p>
+          <a:p>
+            <a:pPr lvl="1">
+              <a:spcAft>
+                <a:spcPts val="400"/>
+              </a:spcAft>
+              <a:defRPr sz="1700">
+                <a:solidFill>
+                  <a:srgbClr val="666666"/>
+                </a:solidFill>
+                <a:latin typeface="Calibri"/>
+              </a:defRPr>
+            </a:pPr>
+            <a:r>
+              <a:t>    Lo que Fabric NO tiene vs Ethereum: ecosistema DeFi, liquidez, interoperabilidad publica,</a:t>
+            </a:r>
+          </a:p>
+          <a:p>
+            <a:pPr lvl="1">
+              <a:spcAft>
+                <a:spcPts val="400"/>
+              </a:spcAft>
+              <a:defRPr sz="1700">
+                <a:solidFill>
+                  <a:srgbClr val="666666"/>
+                </a:solidFill>
+                <a:latin typeface="Calibri"/>
+              </a:defRPr>
+            </a:pPr>
+            <a:r>
+              <a:t>      wallets universales, stablecoins establecidas, herramientas DevTools maduras.</a:t>
+            </a:r>
+          </a:p>
+          <a:p>
+            <a:pPr lvl="1">
+              <a:spcAft>
+                <a:spcPts val="400"/>
+              </a:spcAft>
+              <a:defRPr sz="1700">
+                <a:solidFill>
+                  <a:srgbClr val="666666"/>
+                </a:solidFill>
+                <a:latin typeface="Calibri"/>
+              </a:defRPr>
+            </a:pPr>
+            <a:r>
+              <a:t>    Lo que Fabric SI tiene vs Ethereum: privacidad nativa, rendimiento, gobernanza controlada,</a:t>
+            </a:r>
+          </a:p>
+          <a:p>
+            <a:pPr lvl="1">
+              <a:spcAft>
+                <a:spcPts val="400"/>
+              </a:spcAft>
+              <a:defRPr sz="1700">
+                <a:solidFill>
+                  <a:srgbClr val="666666"/>
+                </a:solidFill>
+                <a:latin typeface="Calibri"/>
+              </a:defRPr>
+            </a:pPr>
+            <a:r>
+              <a:t>      identidades reales, integracion con sistemas legacy, cumplimiento regulatorio.</a:t>
+            </a:r>
+          </a:p>
+          <a:p>
+            <a:pPr lvl="1">
+              <a:spcAft>
+                <a:spcPts val="400"/>
+              </a:spcAft>
+              <a:defRPr sz="1700">
+                <a:solidFill>
+                  <a:srgbClr val="666666"/>
+                </a:solidFill>
+                <a:latin typeface="Calibri"/>
+              </a:defRPr>
+            </a:pPr>
+            <a:r>
+              <a:t>    Conclusion: son para casos de uso distintos, no compiten directamente.</a:t>
+            </a:r>
+          </a:p>
+        </p:txBody>
+      </p:sp>
+    </p:spTree>
+  </p:cSld>
+  <p:clrMapOvr>
+    <a:masterClrMapping/>
+  </p:clrMapOvr>
+</p:sld>
+</file>
+
+<file path=ppt/slides/slide24.xml><?xml version="1.0" encoding="utf-8"?>
+<p:sld xmlns:a="http://schemas.openxmlformats.org/drawingml/2006/main" xmlns:p="http://schemas.openxmlformats.org/presentationml/2006/main" xmlns:r="http://schemas.openxmlformats.org/officeDocument/2006/relationships">
+  <p:cSld>
+    <p:spTree>
+      <p:nvGrpSpPr>
+        <p:cNvPr id="1" name=""/>
+        <p:cNvGrpSpPr/>
+        <p:nvPr/>
+      </p:nvGrpSpPr>
+      <p:grpSpPr/>
+      <p:sp>
+        <p:nvSpPr>
+          <p:cNvPr id="2" name="Rectangle 1"/>
+          <p:cNvSpPr/>
+          <p:nvPr/>
+        </p:nvSpPr>
+        <p:spPr>
+          <a:xfrm>
+            <a:off x="0" y="0"/>
+            <a:ext cx="12188952" cy="73152"/>
+          </a:xfrm>
+          <a:prstGeom prst="rect">
+            <a:avLst/>
+          </a:prstGeom>
+          <a:solidFill>
+            <a:srgbClr val="22627E"/>
+          </a:solidFill>
+          <a:ln>
+            <a:noFill/>
+          </a:ln>
+        </p:spPr>
+        <p:style>
+          <a:lnRef idx="1">
+            <a:schemeClr val="accent1"/>
+          </a:lnRef>
+          <a:fillRef idx="3">
+            <a:schemeClr val="accent1"/>
+          </a:fillRef>
+          <a:effectRef idx="2">
+            <a:schemeClr val="accent1"/>
+          </a:effectRef>
+          <a:fontRef idx="minor">
+            <a:schemeClr val="lt1"/>
+          </a:fontRef>
+        </p:style>
+        <p:txBody>
+          <a:bodyPr rtlCol="0" anchor="ctr"/>
+          <a:lstStyle/>
+          <a:p>
+            <a:pPr algn="ctr"/>
+          </a:p>
+        </p:txBody>
+      </p:sp>
+      <p:sp>
+        <p:nvSpPr>
+          <p:cNvPr id="3" name="TextBox 2"/>
+          <p:cNvSpPr txBox="1"/>
+          <p:nvPr/>
+        </p:nvSpPr>
+        <p:spPr>
+          <a:xfrm>
+            <a:off x="457200" y="274320"/>
+            <a:ext cx="10972800" cy="731520"/>
+          </a:xfrm>
+          <a:prstGeom prst="rect">
+            <a:avLst/>
+          </a:prstGeom>
+          <a:noFill/>
+        </p:spPr>
+        <p:txBody>
+          <a:bodyPr wrap="square"/>
+          <a:lstStyle/>
+          <a:p>
+            <a:pPr algn="l">
+              <a:defRPr sz="3200" b="1">
+                <a:solidFill>
+                  <a:srgbClr val="22627E"/>
+                </a:solidFill>
+                <a:latin typeface="Calibri"/>
+              </a:defRPr>
+            </a:pPr>
+            <a:r>
+              <a:t>Respuestas al debate (2/2)</a:t>
+            </a:r>
+          </a:p>
+        </p:txBody>
+      </p:sp>
+      <p:sp>
+        <p:nvSpPr>
+          <p:cNvPr id="4" name="Rectangle 3"/>
+          <p:cNvSpPr/>
+          <p:nvPr/>
+        </p:nvSpPr>
+        <p:spPr>
+          <a:xfrm>
+            <a:off x="457200" y="1051560"/>
+            <a:ext cx="10972800" cy="27432"/>
+          </a:xfrm>
+          <a:prstGeom prst="rect">
+            <a:avLst/>
+          </a:prstGeom>
+          <a:solidFill>
+            <a:srgbClr val="22627E"/>
+          </a:solidFill>
+          <a:ln>
+            <a:noFill/>
+          </a:ln>
+        </p:spPr>
+        <p:style>
+          <a:lnRef idx="1">
+            <a:schemeClr val="accent1"/>
+          </a:lnRef>
+          <a:fillRef idx="3">
+            <a:schemeClr val="accent1"/>
+          </a:fillRef>
+          <a:effectRef idx="2">
+            <a:schemeClr val="accent1"/>
+          </a:effectRef>
+          <a:fontRef idx="minor">
+            <a:schemeClr val="lt1"/>
+          </a:fontRef>
+        </p:style>
+        <p:txBody>
+          <a:bodyPr rtlCol="0" anchor="ctr"/>
+          <a:lstStyle/>
+          <a:p>
+            <a:pPr algn="ctr"/>
+          </a:p>
+        </p:txBody>
+      </p:sp>
+      <p:sp>
+        <p:nvSpPr>
+          <p:cNvPr id="5" name="TextBox 4"/>
+          <p:cNvSpPr txBox="1"/>
+          <p:nvPr/>
+        </p:nvSpPr>
+        <p:spPr>
+          <a:xfrm>
+            <a:off x="640080" y="1280160"/>
+            <a:ext cx="10515600" cy="5029200"/>
+          </a:xfrm>
+          <a:prstGeom prst="rect">
+            <a:avLst/>
+          </a:prstGeom>
+          <a:noFill/>
+        </p:spPr>
+        <p:txBody>
+          <a:bodyPr wrap="square">
+            <a:spAutoFit/>
+          </a:bodyPr>
+          <a:lstStyle/>
+          <a:p>
+            <a:pPr>
+              <a:spcAft>
+                <a:spcPts val="800"/>
+              </a:spcAft>
+              <a:defRPr sz="2000">
+                <a:solidFill>
+                  <a:srgbClr val="333333"/>
+                </a:solidFill>
+                <a:latin typeface="Calibri"/>
+              </a:defRPr>
+            </a:pPr>
+            <a:r>
+              <a:t>4. Arquitectura para un proyecto real manana:</a:t>
+            </a:r>
+          </a:p>
+          <a:p>
+            <a:pPr lvl="1">
+              <a:spcAft>
+                <a:spcPts val="400"/>
+              </a:spcAft>
+              <a:defRPr sz="1700">
+                <a:solidFill>
+                  <a:srgbClr val="666666"/>
+                </a:solidFill>
+                <a:latin typeface="Calibri"/>
+              </a:defRPr>
+            </a:pPr>
+            <a:r>
+              <a:t>    Empezar pequeno: MVP con 2 orgs, 1 canal, 1 chaincode simple.</a:t>
+            </a:r>
+          </a:p>
+          <a:p>
+            <a:pPr lvl="1">
+              <a:spcAft>
+                <a:spcPts val="400"/>
+              </a:spcAft>
+              <a:defRPr sz="1700">
+                <a:solidFill>
+                  <a:srgbClr val="666666"/>
+                </a:solidFill>
+                <a:latin typeface="Calibri"/>
+              </a:defRPr>
+            </a:pPr>
+            <a:r>
+              <a:t>    Cryptogen para desarrollo, Fabric CA para produccion.</a:t>
+            </a:r>
+          </a:p>
+          <a:p>
+            <a:pPr lvl="1">
+              <a:spcAft>
+                <a:spcPts val="400"/>
+              </a:spcAft>
+              <a:defRPr sz="1700">
+                <a:solidFill>
+                  <a:srgbClr val="666666"/>
+                </a:solidFill>
+                <a:latin typeface="Calibri"/>
+              </a:defRPr>
+            </a:pPr>
+            <a:r>
+              <a:t>    CouchDB si necesitas rich queries (la mayoria de casos).</a:t>
+            </a:r>
+          </a:p>
+          <a:p>
+            <a:pPr lvl="1">
+              <a:spcAft>
+                <a:spcPts val="400"/>
+              </a:spcAft>
+              <a:defRPr sz="1700">
+                <a:solidFill>
+                  <a:srgbClr val="666666"/>
+                </a:solidFill>
+                <a:latin typeface="Calibri"/>
+              </a:defRPr>
+            </a:pPr>
+            <a:r>
+              <a:t>    Gateway SDK en el cliente (ya no se usa el SDK antiguo).</a:t>
+            </a:r>
+          </a:p>
+          <a:p>
+            <a:pPr lvl="1">
+              <a:spcAft>
+                <a:spcPts val="400"/>
+              </a:spcAft>
+              <a:defRPr sz="1700">
+                <a:solidFill>
+                  <a:srgbClr val="666666"/>
+                </a:solidFill>
+                <a:latin typeface="Calibri"/>
+              </a:defRPr>
+            </a:pPr>
+            <a:r>
+              <a:t>    Monitorizacion desde el dia 1: Prometheus + Grafana.</a:t>
+            </a:r>
+          </a:p>
+          <a:p>
+            <a:pPr lvl="1">
+              <a:spcAft>
+                <a:spcPts val="400"/>
+              </a:spcAft>
+              <a:defRPr sz="1700">
+                <a:solidFill>
+                  <a:srgbClr val="666666"/>
+                </a:solidFill>
+                <a:latin typeface="Calibri"/>
+              </a:defRPr>
+            </a:pPr>
+            <a:r>
+              <a:t>    Gobernanza clara ANTES de la tecnologia: ¿quien decide? ¿quien paga?</a:t>
+            </a:r>
+          </a:p>
+          <a:p>
+            <a:pPr>
+              <a:spcAft>
+                <a:spcPts val="800"/>
+              </a:spcAft>
+              <a:defRPr sz="2000">
+                <a:solidFill>
+                  <a:srgbClr val="333333"/>
+                </a:solidFill>
+                <a:latin typeface="Calibri"/>
+              </a:defRPr>
+            </a:pPr>
+            <a:r>
+              <a:t>5. Papel de la IA en el desarrollo de chaincodes:</a:t>
+            </a:r>
+          </a:p>
+          <a:p>
+            <a:pPr lvl="1">
+              <a:spcAft>
+                <a:spcPts val="400"/>
+              </a:spcAft>
+              <a:defRPr sz="1700">
+                <a:solidFill>
+                  <a:srgbClr val="666666"/>
+                </a:solidFill>
+                <a:latin typeface="Calibri"/>
+              </a:defRPr>
+            </a:pPr>
+            <a:r>
+              <a:t>    Generacion de chaincode basico desde especificacion (prompts -&gt; codigo).</a:t>
+            </a:r>
+          </a:p>
+          <a:p>
+            <a:pPr lvl="1">
+              <a:spcAft>
+                <a:spcPts val="400"/>
+              </a:spcAft>
+              <a:defRPr sz="1700">
+                <a:solidFill>
+                  <a:srgbClr val="666666"/>
+                </a:solidFill>
+                <a:latin typeface="Calibri"/>
+              </a:defRPr>
+            </a:pPr>
+            <a:r>
+              <a:t>    Auditoria automatica: detectar errores de determinismo, validaciones faltantes.</a:t>
+            </a:r>
+          </a:p>
+          <a:p>
+            <a:pPr lvl="1">
+              <a:spcAft>
+                <a:spcPts val="400"/>
+              </a:spcAft>
+              <a:defRPr sz="1700">
+                <a:solidFill>
+                  <a:srgbClr val="666666"/>
+                </a:solidFill>
+                <a:latin typeface="Calibri"/>
+              </a:defRPr>
+            </a:pPr>
+            <a:r>
+              <a:t>    Tests generados automaticamente a partir del codigo.</a:t>
+            </a:r>
+          </a:p>
+          <a:p>
+            <a:pPr lvl="1">
+              <a:spcAft>
+                <a:spcPts val="400"/>
+              </a:spcAft>
+              <a:defRPr sz="1700">
+                <a:solidFill>
+                  <a:srgbClr val="666666"/>
+                </a:solidFill>
+                <a:latin typeface="Calibri"/>
+              </a:defRPr>
+            </a:pPr>
+            <a:r>
+              <a:t>    Documentacion y diagramas generados.</a:t>
+            </a:r>
+          </a:p>
+          <a:p>
+            <a:pPr lvl="1">
+              <a:spcAft>
+                <a:spcPts val="400"/>
+              </a:spcAft>
+              <a:defRPr sz="1700">
+                <a:solidFill>
+                  <a:srgbClr val="666666"/>
+                </a:solidFill>
+                <a:latin typeface="Calibri"/>
+              </a:defRPr>
+            </a:pPr>
+            <a:r>
+              <a:t>    Riesgos: la IA no entiende el contexto de negocio, puede generar codigo plausible pero</a:t>
+            </a:r>
+          </a:p>
+          <a:p>
+            <a:pPr lvl="1">
+              <a:spcAft>
+                <a:spcPts val="400"/>
+              </a:spcAft>
+              <a:defRPr sz="1700">
+                <a:solidFill>
+                  <a:srgbClr val="666666"/>
+                </a:solidFill>
+                <a:latin typeface="Calibri"/>
+              </a:defRPr>
+            </a:pPr>
+            <a:r>
+              <a:t>      incorrecto. Siempre revisar manualmente, especialmente validaciones y control de acceso.</a:t>
+            </a:r>
+          </a:p>
+        </p:txBody>
+      </p:sp>
+    </p:spTree>
+  </p:cSld>
+  <p:clrMapOvr>
+    <a:masterClrMapping/>
+  </p:clrMapOvr>
+</p:sld>
+</file>
+
+<file path=ppt/slides/slide25.xml><?xml version="1.0" encoding="utf-8"?>
+<p:sld xmlns:a="http://schemas.openxmlformats.org/drawingml/2006/main" xmlns:p="http://schemas.openxmlformats.org/presentationml/2006/main" xmlns:r="http://schemas.openxmlformats.org/officeDocument/2006/relationships">
+  <p:cSld>
+    <p:spTree>
+      <p:nvGrpSpPr>
+        <p:cNvPr id="1" name=""/>
+        <p:cNvGrpSpPr/>
+        <p:nvPr/>
+      </p:nvGrpSpPr>
+      <p:grpSpPr/>
+      <p:sp>
+        <p:nvSpPr>
+          <p:cNvPr id="2" name="Rectangle 1"/>
+          <p:cNvSpPr/>
+          <p:nvPr/>
+        </p:nvSpPr>
+        <p:spPr>
+          <a:xfrm>
+            <a:off x="0" y="0"/>
+            <a:ext cx="12188952" cy="73152"/>
+          </a:xfrm>
+          <a:prstGeom prst="rect">
+            <a:avLst/>
+          </a:prstGeom>
+          <a:solidFill>
+            <a:srgbClr val="22627E"/>
+          </a:solidFill>
+          <a:ln>
+            <a:noFill/>
+          </a:ln>
+        </p:spPr>
+        <p:style>
+          <a:lnRef idx="1">
+            <a:schemeClr val="accent1"/>
+          </a:lnRef>
+          <a:fillRef idx="3">
+            <a:schemeClr val="accent1"/>
+          </a:fillRef>
+          <a:effectRef idx="2">
+            <a:schemeClr val="accent1"/>
+          </a:effectRef>
+          <a:fontRef idx="minor">
+            <a:schemeClr val="lt1"/>
+          </a:fontRef>
+        </p:style>
+        <p:txBody>
+          <a:bodyPr rtlCol="0" anchor="ctr"/>
+          <a:lstStyle/>
+          <a:p>
+            <a:pPr algn="ctr"/>
+          </a:p>
+        </p:txBody>
+      </p:sp>
+      <p:sp>
+        <p:nvSpPr>
+          <p:cNvPr id="3" name="TextBox 2"/>
+          <p:cNvSpPr txBox="1"/>
+          <p:nvPr/>
+        </p:nvSpPr>
+        <p:spPr>
+          <a:xfrm>
+            <a:off x="457200" y="274320"/>
+            <a:ext cx="10972800" cy="731520"/>
+          </a:xfrm>
+          <a:prstGeom prst="rect">
+            <a:avLst/>
+          </a:prstGeom>
+          <a:noFill/>
+        </p:spPr>
+        <p:txBody>
+          <a:bodyPr wrap="square"/>
+          <a:lstStyle/>
+          <a:p>
+            <a:pPr algn="l">
+              <a:defRPr sz="3200" b="1">
+                <a:solidFill>
+                  <a:srgbClr val="22627E"/>
+                </a:solidFill>
+                <a:latin typeface="Calibri"/>
+              </a:defRPr>
+            </a:pPr>
+            <a:r>
+              <a:t>Respuestas al repaso (1/2)</a:t>
+            </a:r>
+          </a:p>
+        </p:txBody>
+      </p:sp>
+      <p:sp>
+        <p:nvSpPr>
+          <p:cNvPr id="4" name="Rectangle 3"/>
+          <p:cNvSpPr/>
+          <p:nvPr/>
+        </p:nvSpPr>
+        <p:spPr>
+          <a:xfrm>
+            <a:off x="457200" y="1051560"/>
+            <a:ext cx="10972800" cy="27432"/>
+          </a:xfrm>
+          <a:prstGeom prst="rect">
+            <a:avLst/>
+          </a:prstGeom>
+          <a:solidFill>
+            <a:srgbClr val="22627E"/>
+          </a:solidFill>
+          <a:ln>
+            <a:noFill/>
+          </a:ln>
+        </p:spPr>
+        <p:style>
+          <a:lnRef idx="1">
+            <a:schemeClr val="accent1"/>
+          </a:lnRef>
+          <a:fillRef idx="3">
+            <a:schemeClr val="accent1"/>
+          </a:fillRef>
+          <a:effectRef idx="2">
+            <a:schemeClr val="accent1"/>
+          </a:effectRef>
+          <a:fontRef idx="minor">
+            <a:schemeClr val="lt1"/>
+          </a:fontRef>
+        </p:style>
+        <p:txBody>
+          <a:bodyPr rtlCol="0" anchor="ctr"/>
+          <a:lstStyle/>
+          <a:p>
+            <a:pPr algn="ctr"/>
+          </a:p>
+        </p:txBody>
+      </p:sp>
+      <p:sp>
+        <p:nvSpPr>
+          <p:cNvPr id="5" name="TextBox 4"/>
+          <p:cNvSpPr txBox="1"/>
+          <p:nvPr/>
+        </p:nvSpPr>
+        <p:spPr>
+          <a:xfrm>
+            <a:off x="640080" y="1280160"/>
+            <a:ext cx="10515600" cy="5029200"/>
+          </a:xfrm>
+          <a:prstGeom prst="rect">
+            <a:avLst/>
+          </a:prstGeom>
+          <a:noFill/>
+        </p:spPr>
+        <p:txBody>
+          <a:bodyPr wrap="square">
+            <a:spAutoFit/>
+          </a:bodyPr>
+          <a:lstStyle/>
+          <a:p>
+            <a:pPr>
+              <a:spcAft>
+                <a:spcPts val="800"/>
+              </a:spcAft>
+              <a:defRPr sz="2000">
+                <a:solidFill>
+                  <a:srgbClr val="333333"/>
+                </a:solidFill>
+                <a:latin typeface="Calibri"/>
+              </a:defRPr>
+            </a:pPr>
+            <a:r>
+              <a:t>1. Tokenizacion Fabric vs Ethereum:</a:t>
+            </a:r>
+          </a:p>
+          <a:p>
+            <a:pPr lvl="1">
+              <a:spcAft>
+                <a:spcPts val="400"/>
+              </a:spcAft>
+              <a:defRPr sz="1700">
+                <a:solidFill>
+                  <a:srgbClr val="666666"/>
+                </a:solidFill>
+                <a:latin typeface="Calibri"/>
+              </a:defRPr>
+            </a:pPr>
+            <a:r>
+              <a:t>    Ethereum: ERC-20/721/1155 estandar, publico, anyone-can-deploy.</a:t>
+            </a:r>
+          </a:p>
+          <a:p>
+            <a:pPr lvl="1">
+              <a:spcAft>
+                <a:spcPts val="400"/>
+              </a:spcAft>
+              <a:defRPr sz="1700">
+                <a:solidFill>
+                  <a:srgbClr val="666666"/>
+                </a:solidFill>
+                <a:latin typeface="Calibri"/>
+              </a:defRPr>
+            </a:pPr>
+            <a:r>
+              <a:t>    Fabric: sin estandar (aun), permissioned, identidades con certificado.</a:t>
+            </a:r>
+          </a:p>
+          <a:p>
+            <a:pPr>
+              <a:spcAft>
+                <a:spcPts val="800"/>
+              </a:spcAft>
+              <a:defRPr sz="2000">
+                <a:solidFill>
+                  <a:srgbClr val="333333"/>
+                </a:solidFill>
+                <a:latin typeface="Calibri"/>
+              </a:defRPr>
+            </a:pPr>
+            <a:r>
+              <a:t>2. Tres formas de implementar tokens en Fabric:</a:t>
+            </a:r>
+          </a:p>
+          <a:p>
+            <a:pPr lvl="1">
+              <a:spcAft>
+                <a:spcPts val="400"/>
+              </a:spcAft>
+              <a:defRPr sz="1700">
+                <a:solidFill>
+                  <a:srgbClr val="666666"/>
+                </a:solidFill>
+                <a:latin typeface="Calibri"/>
+              </a:defRPr>
+            </a:pPr>
+            <a:r>
+              <a:t>    Chaincode custom desde cero (maximo control).</a:t>
+            </a:r>
+          </a:p>
+          <a:p>
+            <a:pPr lvl="1">
+              <a:spcAft>
+                <a:spcPts val="400"/>
+              </a:spcAft>
+              <a:defRPr sz="1700">
+                <a:solidFill>
+                  <a:srgbClr val="666666"/>
+                </a:solidFill>
+                <a:latin typeface="Calibri"/>
+              </a:defRPr>
+            </a:pPr>
+            <a:r>
+              <a:t>    Fabric Token SDK (UTXO, mejor privacidad).</a:t>
+            </a:r>
+          </a:p>
+          <a:p>
+            <a:pPr lvl="1">
+              <a:spcAft>
+                <a:spcPts val="400"/>
+              </a:spcAft>
+              <a:defRPr sz="1700">
+                <a:solidFill>
+                  <a:srgbClr val="666666"/>
+                </a:solidFill>
+                <a:latin typeface="Calibri"/>
+              </a:defRPr>
+            </a:pPr>
+            <a:r>
+              <a:t>    fabric-samples/token-erc-20 (modelo de cuentas, mas simple).</a:t>
+            </a:r>
+          </a:p>
+          <a:p>
+            <a:pPr>
+              <a:spcAft>
+                <a:spcPts val="800"/>
+              </a:spcAft>
+              <a:defRPr sz="2000">
+                <a:solidFill>
+                  <a:srgbClr val="333333"/>
+                </a:solidFill>
+                <a:latin typeface="Calibri"/>
+              </a:defRPr>
+            </a:pPr>
+            <a:r>
+              <a:t>3. Anatomia de un chaincode:</a:t>
+            </a:r>
+          </a:p>
+          <a:p>
+            <a:pPr lvl="1">
+              <a:spcAft>
+                <a:spcPts val="400"/>
+              </a:spcAft>
+              <a:defRPr sz="1700">
+                <a:solidFill>
+                  <a:srgbClr val="666666"/>
+                </a:solidFill>
+                <a:latin typeface="Calibri"/>
+              </a:defRPr>
+            </a:pPr>
+            <a:r>
+              <a:t>    Struct con contractapi.Contract embebido (Go) o clase que extiende Contract (Node.js).</a:t>
+            </a:r>
+          </a:p>
+          <a:p>
+            <a:pPr lvl="1">
+              <a:spcAft>
+                <a:spcPts val="400"/>
+              </a:spcAft>
+              <a:defRPr sz="1700">
+                <a:solidFill>
+                  <a:srgbClr val="666666"/>
+                </a:solidFill>
+                <a:latin typeface="Calibri"/>
+              </a:defRPr>
+            </a:pPr>
+            <a:r>
+              <a:t>    Funciones reciben ctx: TransactionContextInterface (da acceso al Stub e Identity).</a:t>
+            </a:r>
+          </a:p>
+          <a:p>
+            <a:pPr lvl="1">
+              <a:spcAft>
+                <a:spcPts val="400"/>
+              </a:spcAft>
+              <a:defRPr sz="1700">
+                <a:solidFill>
+                  <a:srgbClr val="666666"/>
+                </a:solidFill>
+                <a:latin typeface="Calibri"/>
+              </a:defRPr>
+            </a:pPr>
+            <a:r>
+              <a:t>    Stub API: GetState, PutState, DelState, GetQueryResult, SetEvent, etc.</a:t>
+            </a:r>
+          </a:p>
+          <a:p>
+            <a:pPr>
+              <a:spcAft>
+                <a:spcPts val="800"/>
+              </a:spcAft>
+              <a:defRPr sz="2000">
+                <a:solidFill>
+                  <a:srgbClr val="333333"/>
+                </a:solidFill>
+                <a:latin typeface="Calibri"/>
+              </a:defRPr>
+            </a:pPr>
+            <a:r>
+              <a:t>4. CRUD + modelado de datos:</a:t>
+            </a:r>
+          </a:p>
+          <a:p>
+            <a:pPr lvl="1">
+              <a:spcAft>
+                <a:spcPts val="400"/>
+              </a:spcAft>
+              <a:defRPr sz="1700">
+                <a:solidFill>
+                  <a:srgbClr val="666666"/>
+                </a:solidFill>
+                <a:latin typeface="Calibri"/>
+              </a:defRPr>
+            </a:pPr>
+            <a:r>
+              <a:t>    CRUD = Create, Read, Update, Delete (logico).</a:t>
+            </a:r>
+          </a:p>
+          <a:p>
+            <a:pPr lvl="1">
+              <a:spcAft>
+                <a:spcPts val="400"/>
+              </a:spcAft>
+              <a:defRPr sz="1700">
+                <a:solidFill>
+                  <a:srgbClr val="666666"/>
+                </a:solidFill>
+                <a:latin typeface="Calibri"/>
+              </a:defRPr>
+            </a:pPr>
+            <a:r>
+              <a:t>    Usar docType en JSON para queries CouchDB.</a:t>
+            </a:r>
+          </a:p>
+          <a:p>
+            <a:pPr lvl="1">
+              <a:spcAft>
+                <a:spcPts val="400"/>
+              </a:spcAft>
+              <a:defRPr sz="1700">
+                <a:solidFill>
+                  <a:srgbClr val="666666"/>
+                </a:solidFill>
+                <a:latin typeface="Calibri"/>
+              </a:defRPr>
+            </a:pPr>
+            <a:r>
+              <a:t>    Composite keys cuando necesitas indices secundarios.</a:t>
+            </a:r>
+          </a:p>
+          <a:p>
+            <a:pPr lvl="1">
+              <a:spcAft>
+                <a:spcPts val="400"/>
+              </a:spcAft>
+              <a:defRPr sz="1700">
+                <a:solidFill>
+                  <a:srgbClr val="666666"/>
+                </a:solidFill>
+                <a:latin typeface="Calibri"/>
+              </a:defRPr>
+            </a:pPr>
+            <a:r>
+              <a:t>    Paginar queries grandes con GetStateByRangeWithPagination.</a:t>
+            </a:r>
+          </a:p>
+          <a:p>
+            <a:pPr>
+              <a:spcAft>
+                <a:spcPts val="800"/>
+              </a:spcAft>
+              <a:defRPr sz="2000">
+                <a:solidFill>
+                  <a:srgbClr val="333333"/>
+                </a:solidFill>
+                <a:latin typeface="Calibri"/>
+              </a:defRPr>
+            </a:pPr>
+            <a:r>
+              <a:t>5. Control de acceso (MSPID + ABAC):</a:t>
+            </a:r>
+          </a:p>
+          <a:p>
+            <a:pPr lvl="1">
+              <a:spcAft>
+                <a:spcPts val="400"/>
+              </a:spcAft>
+              <a:defRPr sz="1700">
+                <a:solidFill>
+                  <a:srgbClr val="666666"/>
+                </a:solidFill>
+                <a:latin typeface="Calibri"/>
+              </a:defRPr>
+            </a:pPr>
+            <a:r>
+              <a:t>    MSPID: que organizacion llama (HotelMSP, CafeteriaMSP).</a:t>
+            </a:r>
+          </a:p>
+          <a:p>
+            <a:pPr lvl="1">
+              <a:spcAft>
+                <a:spcPts val="400"/>
+              </a:spcAft>
+              <a:defRPr sz="1700">
+                <a:solidFill>
+                  <a:srgbClr val="666666"/>
+                </a:solidFill>
+                <a:latin typeface="Calibri"/>
+              </a:defRPr>
+            </a:pPr>
+            <a:r>
+              <a:t>    ABAC: atributos custom del certificado X.509 (role=minter, etc.).</a:t>
+            </a:r>
+          </a:p>
+          <a:p>
+            <a:pPr lvl="1">
+              <a:spcAft>
+                <a:spcPts val="400"/>
+              </a:spcAft>
+              <a:defRPr sz="1700">
+                <a:solidFill>
+                  <a:srgbClr val="666666"/>
+                </a:solidFill>
+                <a:latin typeface="Calibri"/>
+              </a:defRPr>
+            </a:pPr>
+            <a:r>
+              <a:t>    MSPID para separar orgs, ABAC para separar roles dentro de una org.</a:t>
+            </a:r>
+          </a:p>
+        </p:txBody>
+      </p:sp>
+    </p:spTree>
+  </p:cSld>
+  <p:clrMapOvr>
+    <a:masterClrMapping/>
+  </p:clrMapOvr>
+</p:sld>
+</file>
+
+<file path=ppt/slides/slide26.xml><?xml version="1.0" encoding="utf-8"?>
+<p:sld xmlns:a="http://schemas.openxmlformats.org/drawingml/2006/main" xmlns:p="http://schemas.openxmlformats.org/presentationml/2006/main" xmlns:r="http://schemas.openxmlformats.org/officeDocument/2006/relationships">
+  <p:cSld>
+    <p:spTree>
+      <p:nvGrpSpPr>
+        <p:cNvPr id="1" name=""/>
+        <p:cNvGrpSpPr/>
+        <p:nvPr/>
+      </p:nvGrpSpPr>
+      <p:grpSpPr/>
+      <p:sp>
+        <p:nvSpPr>
+          <p:cNvPr id="2" name="Rectangle 1"/>
+          <p:cNvSpPr/>
+          <p:nvPr/>
+        </p:nvSpPr>
+        <p:spPr>
+          <a:xfrm>
+            <a:off x="0" y="0"/>
+            <a:ext cx="12188952" cy="73152"/>
+          </a:xfrm>
+          <a:prstGeom prst="rect">
+            <a:avLst/>
+          </a:prstGeom>
+          <a:solidFill>
+            <a:srgbClr val="22627E"/>
+          </a:solidFill>
+          <a:ln>
+            <a:noFill/>
+          </a:ln>
+        </p:spPr>
+        <p:style>
+          <a:lnRef idx="1">
+            <a:schemeClr val="accent1"/>
+          </a:lnRef>
+          <a:fillRef idx="3">
+            <a:schemeClr val="accent1"/>
+          </a:fillRef>
+          <a:effectRef idx="2">
+            <a:schemeClr val="accent1"/>
+          </a:effectRef>
+          <a:fontRef idx="minor">
+            <a:schemeClr val="lt1"/>
+          </a:fontRef>
+        </p:style>
+        <p:txBody>
+          <a:bodyPr rtlCol="0" anchor="ctr"/>
+          <a:lstStyle/>
+          <a:p>
+            <a:pPr algn="ctr"/>
+          </a:p>
+        </p:txBody>
+      </p:sp>
+      <p:sp>
+        <p:nvSpPr>
+          <p:cNvPr id="3" name="TextBox 2"/>
+          <p:cNvSpPr txBox="1"/>
+          <p:nvPr/>
+        </p:nvSpPr>
+        <p:spPr>
+          <a:xfrm>
+            <a:off x="457200" y="274320"/>
+            <a:ext cx="10972800" cy="731520"/>
+          </a:xfrm>
+          <a:prstGeom prst="rect">
+            <a:avLst/>
+          </a:prstGeom>
+          <a:noFill/>
+        </p:spPr>
+        <p:txBody>
+          <a:bodyPr wrap="square"/>
+          <a:lstStyle/>
+          <a:p>
+            <a:pPr algn="l">
+              <a:defRPr sz="3200" b="1">
+                <a:solidFill>
+                  <a:srgbClr val="22627E"/>
+                </a:solidFill>
+                <a:latin typeface="Calibri"/>
+              </a:defRPr>
+            </a:pPr>
+            <a:r>
+              <a:t>Respuestas al repaso (2/2)</a:t>
+            </a:r>
+          </a:p>
+        </p:txBody>
+      </p:sp>
+      <p:sp>
+        <p:nvSpPr>
+          <p:cNvPr id="4" name="Rectangle 3"/>
+          <p:cNvSpPr/>
+          <p:nvPr/>
+        </p:nvSpPr>
+        <p:spPr>
+          <a:xfrm>
+            <a:off x="457200" y="1051560"/>
+            <a:ext cx="10972800" cy="27432"/>
+          </a:xfrm>
+          <a:prstGeom prst="rect">
+            <a:avLst/>
+          </a:prstGeom>
+          <a:solidFill>
+            <a:srgbClr val="22627E"/>
+          </a:solidFill>
+          <a:ln>
+            <a:noFill/>
+          </a:ln>
+        </p:spPr>
+        <p:style>
+          <a:lnRef idx="1">
+            <a:schemeClr val="accent1"/>
+          </a:lnRef>
+          <a:fillRef idx="3">
+            <a:schemeClr val="accent1"/>
+          </a:fillRef>
+          <a:effectRef idx="2">
+            <a:schemeClr val="accent1"/>
+          </a:effectRef>
+          <a:fontRef idx="minor">
+            <a:schemeClr val="lt1"/>
+          </a:fontRef>
+        </p:style>
+        <p:txBody>
+          <a:bodyPr rtlCol="0" anchor="ctr"/>
+          <a:lstStyle/>
+          <a:p>
+            <a:pPr algn="ctr"/>
+          </a:p>
+        </p:txBody>
+      </p:sp>
+      <p:sp>
+        <p:nvSpPr>
+          <p:cNvPr id="5" name="TextBox 4"/>
+          <p:cNvSpPr txBox="1"/>
+          <p:nvPr/>
+        </p:nvSpPr>
+        <p:spPr>
+          <a:xfrm>
+            <a:off x="640080" y="1280160"/>
+            <a:ext cx="10515600" cy="5029200"/>
+          </a:xfrm>
+          <a:prstGeom prst="rect">
+            <a:avLst/>
+          </a:prstGeom>
+          <a:noFill/>
+        </p:spPr>
+        <p:txBody>
+          <a:bodyPr wrap="square">
+            <a:spAutoFit/>
+          </a:bodyPr>
+          <a:lstStyle/>
+          <a:p>
+            <a:pPr>
+              <a:spcAft>
+                <a:spcPts val="800"/>
+              </a:spcAft>
+              <a:defRPr sz="2000">
+                <a:solidFill>
+                  <a:srgbClr val="333333"/>
+                </a:solidFill>
+                <a:latin typeface="Calibri"/>
+              </a:defRPr>
+            </a:pPr>
+            <a:r>
+              <a:t>6. Private Data Collections:</a:t>
+            </a:r>
+          </a:p>
+          <a:p>
+            <a:pPr lvl="1">
+              <a:spcAft>
+                <a:spcPts val="400"/>
+              </a:spcAft>
+              <a:defRPr sz="1700">
+                <a:solidFill>
+                  <a:srgbClr val="666666"/>
+                </a:solidFill>
+                <a:latin typeface="Calibri"/>
+              </a:defRPr>
+            </a:pPr>
+            <a:r>
+              <a:t>    Compartir datos entre un subconjunto de orgs (no todo el canal).</a:t>
+            </a:r>
+          </a:p>
+          <a:p>
+            <a:pPr lvl="1">
+              <a:spcAft>
+                <a:spcPts val="400"/>
+              </a:spcAft>
+              <a:defRPr sz="1700">
+                <a:solidFill>
+                  <a:srgbClr val="666666"/>
+                </a:solidFill>
+                <a:latin typeface="Calibri"/>
+              </a:defRPr>
+            </a:pPr>
+            <a:r>
+              <a:t>    Definidas en collections_config.json: nombre, policy, blockToLive.</a:t>
+            </a:r>
+          </a:p>
+          <a:p>
+            <a:pPr lvl="1">
+              <a:spcAft>
+                <a:spcPts val="400"/>
+              </a:spcAft>
+              <a:defRPr sz="1700">
+                <a:solidFill>
+                  <a:srgbClr val="666666"/>
+                </a:solidFill>
+                <a:latin typeface="Calibri"/>
+              </a:defRPr>
+            </a:pPr>
+            <a:r>
+              <a:t>    Datos reales en la BD privada del peer, hash en el ledger publico.</a:t>
+            </a:r>
+          </a:p>
+          <a:p>
+            <a:pPr>
+              <a:spcAft>
+                <a:spcPts val="800"/>
+              </a:spcAft>
+              <a:defRPr sz="2000">
+                <a:solidFill>
+                  <a:srgbClr val="333333"/>
+                </a:solidFill>
+                <a:latin typeface="Calibri"/>
+              </a:defRPr>
+            </a:pPr>
+            <a:r>
+              <a:t>7. Tokens fungibles vs NFT en Fabric:</a:t>
+            </a:r>
+          </a:p>
+          <a:p>
+            <a:pPr lvl="1">
+              <a:spcAft>
+                <a:spcPts val="400"/>
+              </a:spcAft>
+              <a:defRPr sz="1700">
+                <a:solidFill>
+                  <a:srgbClr val="666666"/>
+                </a:solidFill>
+                <a:latin typeface="Calibri"/>
+              </a:defRPr>
+            </a:pPr>
+            <a:r>
+              <a:t>    Fungible: balance por cuenta, tipo ERC-20.</a:t>
+            </a:r>
+          </a:p>
+          <a:p>
+            <a:pPr lvl="1">
+              <a:spcAft>
+                <a:spcPts val="400"/>
+              </a:spcAft>
+              <a:defRPr sz="1700">
+                <a:solidFill>
+                  <a:srgbClr val="666666"/>
+                </a:solidFill>
+                <a:latin typeface="Calibri"/>
+              </a:defRPr>
+            </a:pPr>
+            <a:r>
+              <a:t>    NFT: cada token unico con tokenID y metadata, composite keys por owner.</a:t>
+            </a:r>
+          </a:p>
+          <a:p>
+            <a:pPr>
+              <a:spcAft>
+                <a:spcPts val="800"/>
+              </a:spcAft>
+              <a:defRPr sz="2000">
+                <a:solidFill>
+                  <a:srgbClr val="333333"/>
+                </a:solidFill>
+                <a:latin typeface="Calibri"/>
+              </a:defRPr>
+            </a:pPr>
+            <a:r>
+              <a:t>8. Seguridad (determinismo, MVCC, checklist):</a:t>
+            </a:r>
+          </a:p>
+          <a:p>
+            <a:pPr lvl="1">
+              <a:spcAft>
+                <a:spcPts val="400"/>
+              </a:spcAft>
+              <a:defRPr sz="1700">
+                <a:solidFill>
+                  <a:srgbClr val="666666"/>
+                </a:solidFill>
+                <a:latin typeface="Calibri"/>
+              </a:defRPr>
+            </a:pPr>
+            <a:r>
+              <a:t>    Determinismo: no usar time.Now, rand, http, map iteration.</a:t>
+            </a:r>
+          </a:p>
+          <a:p>
+            <a:pPr lvl="1">
+              <a:spcAft>
+                <a:spcPts val="400"/>
+              </a:spcAft>
+              <a:defRPr sz="1700">
+                <a:solidFill>
+                  <a:srgbClr val="666666"/>
+                </a:solidFill>
+                <a:latin typeface="Calibri"/>
+              </a:defRPr>
+            </a:pPr>
+            <a:r>
+              <a:t>    MVCC: conflicto cuando 2 transacciones tocan las mismas keys.</a:t>
+            </a:r>
+          </a:p>
+          <a:p>
+            <a:pPr lvl="1">
+              <a:spcAft>
+                <a:spcPts val="400"/>
+              </a:spcAft>
+              <a:defRPr sz="1700">
+                <a:solidFill>
+                  <a:srgbClr val="666666"/>
+                </a:solidFill>
+                <a:latin typeface="Calibri"/>
+              </a:defRPr>
+            </a:pPr>
+            <a:r>
+              <a:t>    Checklist: verificar identidad, validar inputs, paginar queries, no loguear secretos.</a:t>
+            </a:r>
+          </a:p>
+          <a:p>
+            <a:pPr>
+              <a:spcAft>
+                <a:spcPts val="800"/>
+              </a:spcAft>
+              <a:defRPr sz="2000">
+                <a:solidFill>
+                  <a:srgbClr val="333333"/>
+                </a:solidFill>
+                <a:latin typeface="Calibri"/>
+              </a:defRPr>
+            </a:pPr>
+            <a:r>
+              <a:t>9. Gateway SDK:</a:t>
+            </a:r>
+          </a:p>
+          <a:p>
+            <a:pPr lvl="1">
+              <a:spcAft>
+                <a:spcPts val="400"/>
+              </a:spcAft>
+              <a:defRPr sz="1700">
+                <a:solidFill>
+                  <a:srgbClr val="666666"/>
+                </a:solidFill>
+                <a:latin typeface="Calibri"/>
+              </a:defRPr>
+            </a:pPr>
+            <a:r>
+              <a:t>    Libreria cliente para conectar apps con la red Fabric.</a:t>
+            </a:r>
+          </a:p>
+          <a:p>
+            <a:pPr lvl="1">
+              <a:spcAft>
+                <a:spcPts val="400"/>
+              </a:spcAft>
+              <a:defRPr sz="1700">
+                <a:solidFill>
+                  <a:srgbClr val="666666"/>
+                </a:solidFill>
+                <a:latin typeface="Calibri"/>
+              </a:defRPr>
+            </a:pPr>
+            <a:r>
+              <a:t>    Flujo: wallet -&gt; gateway -&gt; peer -&gt; chaincode.</a:t>
+            </a:r>
+          </a:p>
+          <a:p>
+            <a:pPr lvl="1">
+              <a:spcAft>
+                <a:spcPts val="400"/>
+              </a:spcAft>
+              <a:defRPr sz="1700">
+                <a:solidFill>
+                  <a:srgbClr val="666666"/>
+                </a:solidFill>
+                <a:latin typeface="Calibri"/>
+              </a:defRPr>
+            </a:pPr>
+            <a:r>
+              <a:t>    submitTransaction (escritura) vs evaluateTransaction (lectura).</a:t>
+            </a:r>
+          </a:p>
+          <a:p>
+            <a:pPr>
+              <a:spcAft>
+                <a:spcPts val="800"/>
+              </a:spcAft>
+              <a:defRPr sz="2000">
+                <a:solidFill>
+                  <a:srgbClr val="333333"/>
+                </a:solidFill>
+                <a:latin typeface="Calibri"/>
+              </a:defRPr>
+            </a:pPr>
+            <a:r>
+              <a:t>10. Testing con mocks:</a:t>
+            </a:r>
+          </a:p>
+          <a:p>
+            <a:pPr lvl="1">
+              <a:spcAft>
+                <a:spcPts val="400"/>
+              </a:spcAft>
+              <a:defRPr sz="1700">
+                <a:solidFill>
+                  <a:srgbClr val="666666"/>
+                </a:solidFill>
+                <a:latin typeface="Calibri"/>
+              </a:defRPr>
+            </a:pPr>
+            <a:r>
+              <a:t>    Mockear ctx, stub e clientIdentity con sinon/testify.</a:t>
+            </a:r>
+          </a:p>
+          <a:p>
+            <a:pPr lvl="1">
+              <a:spcAft>
+                <a:spcPts val="400"/>
+              </a:spcAft>
+              <a:defRPr sz="1700">
+                <a:solidFill>
+                  <a:srgbClr val="666666"/>
+                </a:solidFill>
+                <a:latin typeface="Calibri"/>
+              </a:defRPr>
+            </a:pPr>
+            <a:r>
+              <a:t>    Configurar respuestas esperadas: getState.resolves(...), etc.</a:t>
+            </a:r>
+          </a:p>
+          <a:p>
+            <a:pPr lvl="1">
+              <a:spcAft>
+                <a:spcPts val="400"/>
+              </a:spcAft>
+              <a:defRPr sz="1700">
+                <a:solidFill>
+                  <a:srgbClr val="666666"/>
+                </a:solidFill>
+                <a:latin typeface="Calibri"/>
+              </a:defRPr>
+            </a:pPr>
+            <a:r>
+              <a:t>    Verificar que se llamaron las funciones correctas (putState, setEvent).</a:t>
+            </a:r>
+          </a:p>
+        </p:txBody>
+      </p:sp>
+    </p:spTree>
+  </p:cSld>
+  <p:clrMapOvr>
+    <a:masterClrMapping/>
+  </p:clrMapOvr>
+</p:sld>
+</file>
+
 <file path=ppt/slides/slide3.xml><?xml version="1.0" encoding="utf-8"?>
 <p:sld xmlns:a="http://schemas.openxmlformats.org/drawingml/2006/main" xmlns:r="http://schemas.openxmlformats.org/officeDocument/2006/relationships" xmlns:p="http://schemas.openxmlformats.org/presentationml/2006/main">
   <p:cSld>
@@ -14689,7 +15557,7 @@
               </a:defRPr>
             </a:pPr>
             <a:r>
-              <a:t>Gateway SDK: conexion en Go</a:t>
+              <a:t>Gateway SDK: conexion en Node.js</a:t>
             </a:r>
           </a:p>
         </p:txBody>
@@ -14801,7 +15669,7 @@
               </a:defRPr>
             </a:pPr>
             <a:r>
-              <a:t>GO</a:t>
+              <a:t>NODE.JS</a:t>
             </a:r>
           </a:p>
         </p:txBody>
@@ -14870,7 +15738,8 @@
           <a:bodyPr wrap="square"/>
           <a:lstStyle/>
           <a:p>
-            <a:br>
+            <a:pPr/>
+            <a:r>
               <a:rPr sz="1600" dirty="0">
                 <a:solidFill>
                   <a:schemeClr val="bg1">
@@ -14878,7 +15747,11 @@
                   </a:schemeClr>
                 </a:solidFill>
               </a:rPr>
-            </a:br>
+              <a:t>const { connect, signers } = require(</a:t>
+            </a:r>
+          </a:p>
+          <a:p>
+            <a:pPr/>
             <a:r>
               <a:rPr sz="1600" dirty="0">
                 <a:solidFill>
@@ -14887,9 +15760,12 @@
                   </a:schemeClr>
                 </a:solidFill>
               </a:rPr>
-              <a:t>package main</a:t>
-            </a:r>
-            <a:br>
+              <a:t>    '@hyperledger/fabric-gateway');</a:t>
+            </a:r>
+          </a:p>
+          <a:p>
+            <a:pPr/>
+            <a:r>
               <a:rPr sz="1600" dirty="0">
                 <a:solidFill>
                   <a:schemeClr val="bg1">
@@ -14897,8 +15773,12 @@
                   </a:schemeClr>
                 </a:solidFill>
               </a:rPr>
-            </a:br>
-            <a:br>
+              <a:t>const grpc = require('@grpc/grpc-js');</a:t>
+            </a:r>
+          </a:p>
+          <a:p>
+            <a:pPr/>
+            <a:r>
               <a:rPr sz="1600" dirty="0">
                 <a:solidFill>
                   <a:schemeClr val="bg1">
@@ -14906,7 +15786,11 @@
                   </a:schemeClr>
                 </a:solidFill>
               </a:rPr>
-            </a:br>
+              <a:t>const crypto = require('crypto');</a:t>
+            </a:r>
+          </a:p>
+          <a:p>
+            <a:pPr/>
             <a:r>
               <a:rPr sz="1600" dirty="0">
                 <a:solidFill>
@@ -14915,9 +15799,12 @@
                   </a:schemeClr>
                 </a:solidFill>
               </a:rPr>
-              <a:t>import (</a:t>
-            </a:r>
-            <a:br>
+              <a:t/>
+            </a:r>
+          </a:p>
+          <a:p>
+            <a:pPr/>
+            <a:r>
               <a:rPr sz="1600" dirty="0">
                 <a:solidFill>
                   <a:schemeClr val="bg1">
@@ -14925,7 +15812,11 @@
                   </a:schemeClr>
                 </a:solidFill>
               </a:rPr>
-            </a:br>
+              <a:t>async function main() {</a:t>
+            </a:r>
+          </a:p>
+          <a:p>
+            <a:pPr/>
             <a:r>
               <a:rPr sz="1600" dirty="0">
                 <a:solidFill>
@@ -14934,18 +15825,11 @@
                   </a:schemeClr>
                 </a:solidFill>
               </a:rPr>
-              <a:t>    "github.com/</a:t>
-            </a:r>
-            <a:r>
-              <a:rPr sz="1600" dirty="0" err="1">
-                <a:solidFill>
-                  <a:schemeClr val="bg1">
-                    <a:lumMod val="95000"/>
-                  </a:schemeClr>
-                </a:solidFill>
-              </a:rPr>
-              <a:t>hyperledger</a:t>
-            </a:r>
+              <a:t>    // 1. Conexion gRPC al peer</a:t>
+            </a:r>
+          </a:p>
+          <a:p>
+            <a:pPr/>
             <a:r>
               <a:rPr sz="1600" dirty="0">
                 <a:solidFill>
@@ -14954,9 +15838,12 @@
                   </a:schemeClr>
                 </a:solidFill>
               </a:rPr>
-              <a:t>/fabric-gateway/pkg/client"</a:t>
-            </a:r>
-            <a:br>
+              <a:t>    const client = new grpc.Client(</a:t>
+            </a:r>
+          </a:p>
+          <a:p>
+            <a:pPr/>
+            <a:r>
               <a:rPr sz="1600" dirty="0">
                 <a:solidFill>
                   <a:schemeClr val="bg1">
@@ -14964,7 +15851,11 @@
                   </a:schemeClr>
                 </a:solidFill>
               </a:rPr>
-            </a:br>
+              <a:t>        'localhost:7051',</a:t>
+            </a:r>
+          </a:p>
+          <a:p>
+            <a:pPr/>
             <a:r>
               <a:rPr sz="1600" dirty="0">
                 <a:solidFill>
@@ -14973,18 +15864,11 @@
                   </a:schemeClr>
                 </a:solidFill>
               </a:rPr>
-              <a:t>    "google.golang.org/</a:t>
-            </a:r>
-            <a:r>
-              <a:rPr sz="1600" dirty="0" err="1">
-                <a:solidFill>
-                  <a:schemeClr val="bg1">
-                    <a:lumMod val="95000"/>
-                  </a:schemeClr>
-                </a:solidFill>
-              </a:rPr>
-              <a:t>grpc</a:t>
-            </a:r>
+              <a:t>        grpc.credentials.createSsl(tlsRootCert));</a:t>
+            </a:r>
+          </a:p>
+          <a:p>
+            <a:pPr/>
             <a:r>
               <a:rPr sz="1600" dirty="0">
                 <a:solidFill>
@@ -14993,9 +15877,12 @@
                   </a:schemeClr>
                 </a:solidFill>
               </a:rPr>
-              <a:t>"</a:t>
-            </a:r>
-            <a:br>
+              <a:t/>
+            </a:r>
+          </a:p>
+          <a:p>
+            <a:pPr/>
+            <a:r>
               <a:rPr sz="1600" dirty="0">
                 <a:solidFill>
                   <a:schemeClr val="bg1">
@@ -15003,7 +15890,11 @@
                   </a:schemeClr>
                 </a:solidFill>
               </a:rPr>
-            </a:br>
+              <a:t>    // 2. Crear identidad</a:t>
+            </a:r>
+          </a:p>
+          <a:p>
+            <a:pPr/>
             <a:r>
               <a:rPr sz="1600" dirty="0">
                 <a:solidFill>
@@ -15012,9 +15903,12 @@
                   </a:schemeClr>
                 </a:solidFill>
               </a:rPr>
-              <a:t>    "crypto/x509"</a:t>
-            </a:r>
-            <a:br>
+              <a:t>    const identity = {</a:t>
+            </a:r>
+          </a:p>
+          <a:p>
+            <a:pPr/>
+            <a:r>
               <a:rPr sz="1600" dirty="0">
                 <a:solidFill>
                   <a:schemeClr val="bg1">
@@ -15022,7 +15916,11 @@
                   </a:schemeClr>
                 </a:solidFill>
               </a:rPr>
-            </a:br>
+              <a:t>        mspId: 'Org1MSP',</a:t>
+            </a:r>
+          </a:p>
+          <a:p>
+            <a:pPr/>
             <a:r>
               <a:rPr sz="1600" dirty="0">
                 <a:solidFill>
@@ -15031,9 +15929,12 @@
                   </a:schemeClr>
                 </a:solidFill>
               </a:rPr>
-              <a:t>)</a:t>
-            </a:r>
-            <a:br>
+              <a:t>        credentials: certificate</a:t>
+            </a:r>
+          </a:p>
+          <a:p>
+            <a:pPr/>
+            <a:r>
               <a:rPr sz="1600" dirty="0">
                 <a:solidFill>
                   <a:schemeClr val="bg1">
@@ -15041,8 +15942,12 @@
                   </a:schemeClr>
                 </a:solidFill>
               </a:rPr>
-            </a:br>
-            <a:br>
+              <a:t>    };</a:t>
+            </a:r>
+          </a:p>
+          <a:p>
+            <a:pPr/>
+            <a:r>
               <a:rPr sz="1600" dirty="0">
                 <a:solidFill>
                   <a:schemeClr val="bg1">
@@ -15050,316 +15955,8 @@
                   </a:schemeClr>
                 </a:solidFill>
               </a:rPr>
-            </a:br>
-            <a:r>
-              <a:rPr sz="1600" dirty="0" err="1">
-                <a:solidFill>
-                  <a:schemeClr val="bg1">
-                    <a:lumMod val="95000"/>
-                  </a:schemeClr>
-                </a:solidFill>
-              </a:rPr>
-              <a:t>func</a:t>
-            </a:r>
-            <a:r>
-              <a:rPr sz="1600" dirty="0">
-                <a:solidFill>
-                  <a:schemeClr val="bg1">
-                    <a:lumMod val="95000"/>
-                  </a:schemeClr>
-                </a:solidFill>
-              </a:rPr>
-              <a:t> main() {</a:t>
-            </a:r>
-            <a:br>
-              <a:rPr sz="1600" dirty="0">
-                <a:solidFill>
-                  <a:schemeClr val="bg1">
-                    <a:lumMod val="95000"/>
-                  </a:schemeClr>
-                </a:solidFill>
-              </a:rPr>
-            </a:br>
-            <a:r>
-              <a:rPr sz="1600" dirty="0">
-                <a:solidFill>
-                  <a:schemeClr val="bg1">
-                    <a:lumMod val="95000"/>
-                  </a:schemeClr>
-                </a:solidFill>
-              </a:rPr>
-              <a:t>    // 1. Conexion </a:t>
-            </a:r>
-            <a:r>
-              <a:rPr sz="1600" dirty="0" err="1">
-                <a:solidFill>
-                  <a:schemeClr val="bg1">
-                    <a:lumMod val="95000"/>
-                  </a:schemeClr>
-                </a:solidFill>
-              </a:rPr>
-              <a:t>gRPC</a:t>
-            </a:r>
-            <a:r>
-              <a:rPr sz="1600" dirty="0">
-                <a:solidFill>
-                  <a:schemeClr val="bg1">
-                    <a:lumMod val="95000"/>
-                  </a:schemeClr>
-                </a:solidFill>
-              </a:rPr>
-              <a:t> al peer</a:t>
-            </a:r>
-            <a:br>
-              <a:rPr sz="1600" dirty="0">
-                <a:solidFill>
-                  <a:schemeClr val="bg1">
-                    <a:lumMod val="95000"/>
-                  </a:schemeClr>
-                </a:solidFill>
-              </a:rPr>
-            </a:br>
-            <a:r>
-              <a:rPr sz="1600" dirty="0">
-                <a:solidFill>
-                  <a:schemeClr val="bg1">
-                    <a:lumMod val="95000"/>
-                  </a:schemeClr>
-                </a:solidFill>
-              </a:rPr>
-              <a:t>    </a:t>
-            </a:r>
-            <a:r>
-              <a:rPr sz="1600" dirty="0" err="1">
-                <a:solidFill>
-                  <a:schemeClr val="bg1">
-                    <a:lumMod val="95000"/>
-                  </a:schemeClr>
-                </a:solidFill>
-              </a:rPr>
-              <a:t>clientConnection</a:t>
-            </a:r>
-            <a:r>
-              <a:rPr sz="1600" dirty="0">
-                <a:solidFill>
-                  <a:schemeClr val="bg1">
-                    <a:lumMod val="95000"/>
-                  </a:schemeClr>
-                </a:solidFill>
-              </a:rPr>
-              <a:t>, _ := </a:t>
-            </a:r>
-            <a:r>
-              <a:rPr sz="1600" dirty="0" err="1">
-                <a:solidFill>
-                  <a:schemeClr val="bg1">
-                    <a:lumMod val="95000"/>
-                  </a:schemeClr>
-                </a:solidFill>
-              </a:rPr>
-              <a:t>grpc.NewClient</a:t>
-            </a:r>
-            <a:r>
-              <a:rPr sz="1600" dirty="0">
-                <a:solidFill>
-                  <a:schemeClr val="bg1">
-                    <a:lumMod val="95000"/>
-                  </a:schemeClr>
-                </a:solidFill>
-              </a:rPr>
-              <a:t>("localhost:7051", </a:t>
-            </a:r>
-            <a:r>
-              <a:rPr sz="1600" dirty="0" err="1">
-                <a:solidFill>
-                  <a:schemeClr val="bg1">
-                    <a:lumMod val="95000"/>
-                  </a:schemeClr>
-                </a:solidFill>
-              </a:rPr>
-              <a:t>grpc.WithTransportCredentials</a:t>
-            </a:r>
-            <a:r>
-              <a:rPr sz="1600" dirty="0">
-                <a:solidFill>
-                  <a:schemeClr val="bg1">
-                    <a:lumMod val="95000"/>
-                  </a:schemeClr>
-                </a:solidFill>
-              </a:rPr>
-              <a:t>(...))</a:t>
-            </a:r>
-            <a:br>
-              <a:rPr sz="1600" dirty="0">
-                <a:solidFill>
-                  <a:schemeClr val="bg1">
-                    <a:lumMod val="95000"/>
-                  </a:schemeClr>
-                </a:solidFill>
-              </a:rPr>
-            </a:br>
-            <a:r>
-              <a:rPr sz="1600" dirty="0">
-                <a:solidFill>
-                  <a:schemeClr val="bg1">
-                    <a:lumMod val="95000"/>
-                  </a:schemeClr>
-                </a:solidFill>
-              </a:rPr>
-              <a:t>    defer </a:t>
-            </a:r>
-            <a:r>
-              <a:rPr sz="1600" dirty="0" err="1">
-                <a:solidFill>
-                  <a:schemeClr val="bg1">
-                    <a:lumMod val="95000"/>
-                  </a:schemeClr>
-                </a:solidFill>
-              </a:rPr>
-              <a:t>clientConnection.Close</a:t>
-            </a:r>
-            <a:r>
-              <a:rPr sz="1600" dirty="0">
-                <a:solidFill>
-                  <a:schemeClr val="bg1">
-                    <a:lumMod val="95000"/>
-                  </a:schemeClr>
-                </a:solidFill>
-              </a:rPr>
-              <a:t>()</a:t>
-            </a:r>
-            <a:br>
-              <a:rPr sz="1600" dirty="0">
-                <a:solidFill>
-                  <a:schemeClr val="bg1">
-                    <a:lumMod val="95000"/>
-                  </a:schemeClr>
-                </a:solidFill>
-              </a:rPr>
-            </a:br>
-            <a:br>
-              <a:rPr sz="1600" dirty="0">
-                <a:solidFill>
-                  <a:schemeClr val="bg1">
-                    <a:lumMod val="95000"/>
-                  </a:schemeClr>
-                </a:solidFill>
-              </a:rPr>
-            </a:br>
-            <a:r>
-              <a:rPr sz="1600" dirty="0">
-                <a:solidFill>
-                  <a:schemeClr val="bg1">
-                    <a:lumMod val="95000"/>
-                  </a:schemeClr>
-                </a:solidFill>
-              </a:rPr>
-              <a:t>    // 2. Crear </a:t>
-            </a:r>
-            <a:r>
-              <a:rPr sz="1600" dirty="0" err="1">
-                <a:solidFill>
-                  <a:schemeClr val="bg1">
-                    <a:lumMod val="95000"/>
-                  </a:schemeClr>
-                </a:solidFill>
-              </a:rPr>
-              <a:t>identidad</a:t>
-            </a:r>
-            <a:br>
-              <a:rPr sz="1600" dirty="0">
-                <a:solidFill>
-                  <a:schemeClr val="bg1">
-                    <a:lumMod val="95000"/>
-                  </a:schemeClr>
-                </a:solidFill>
-              </a:rPr>
-            </a:br>
-            <a:r>
-              <a:rPr sz="1600" dirty="0">
-                <a:solidFill>
-                  <a:schemeClr val="bg1">
-                    <a:lumMod val="95000"/>
-                  </a:schemeClr>
-                </a:solidFill>
-              </a:rPr>
-              <a:t>    id := client.NewX509Identity("Org1MSP", certificate)</a:t>
-            </a:r>
-            <a:br>
-              <a:rPr sz="1600" dirty="0">
-                <a:solidFill>
-                  <a:schemeClr val="bg1">
-                    <a:lumMod val="95000"/>
-                  </a:schemeClr>
-                </a:solidFill>
-              </a:rPr>
-            </a:br>
-            <a:r>
-              <a:rPr sz="1600" dirty="0">
-                <a:solidFill>
-                  <a:schemeClr val="bg1">
-                    <a:lumMod val="95000"/>
-                  </a:schemeClr>
-                </a:solidFill>
-              </a:rPr>
-              <a:t>    sign, _ := </a:t>
-            </a:r>
-            <a:r>
-              <a:rPr sz="1600" dirty="0" err="1">
-                <a:solidFill>
-                  <a:schemeClr val="bg1">
-                    <a:lumMod val="95000"/>
-                  </a:schemeClr>
-                </a:solidFill>
-              </a:rPr>
-              <a:t>client.NewSign</a:t>
-            </a:r>
-            <a:r>
-              <a:rPr sz="1600" dirty="0">
-                <a:solidFill>
-                  <a:schemeClr val="bg1">
-                    <a:lumMod val="95000"/>
-                  </a:schemeClr>
-                </a:solidFill>
-              </a:rPr>
-              <a:t>(</a:t>
-            </a:r>
-            <a:r>
-              <a:rPr sz="1600" dirty="0" err="1">
-                <a:solidFill>
-                  <a:schemeClr val="bg1">
-                    <a:lumMod val="95000"/>
-                  </a:schemeClr>
-                </a:solidFill>
-              </a:rPr>
-              <a:t>privateKey</a:t>
-            </a:r>
-            <a:r>
-              <a:rPr sz="1600" dirty="0">
-                <a:solidFill>
-                  <a:schemeClr val="bg1">
-                    <a:lumMod val="95000"/>
-                  </a:schemeClr>
-                </a:solidFill>
-              </a:rPr>
-              <a:t>)</a:t>
-            </a:r>
-            <a:br>
-              <a:rPr sz="1600" dirty="0">
-                <a:solidFill>
-                  <a:schemeClr val="bg1">
-                    <a:lumMod val="95000"/>
-                  </a:schemeClr>
-                </a:solidFill>
-              </a:rPr>
-            </a:br>
-            <a:endParaRPr sz="1600" dirty="0">
-              <a:solidFill>
-                <a:schemeClr val="bg1">
-                  <a:lumMod val="95000"/>
-                </a:schemeClr>
-              </a:solidFill>
-            </a:endParaRPr>
+              <a:t>    const signer = signers.newPrivateKeySigner(privateKey);</a:t>
+            </a:r>
           </a:p>
         </p:txBody>
       </p:sp>
@@ -15391,7 +15988,8 @@
           </a:bodyPr>
           <a:lstStyle/>
           <a:p>
-            <a:br>
+            <a:pPr/>
+            <a:r>
               <a:rPr lang="es-ES" sz="1600" dirty="0">
                 <a:solidFill>
                   <a:schemeClr val="bg1">
@@ -15399,7 +15997,11 @@
                   </a:schemeClr>
                 </a:solidFill>
               </a:rPr>
-            </a:br>
+              <a:t>    // 3. Conectar al Gateway</a:t>
+            </a:r>
+          </a:p>
+          <a:p>
+            <a:pPr/>
             <a:r>
               <a:rPr lang="es-ES" sz="1600" dirty="0">
                 <a:solidFill>
@@ -15408,9 +16010,12 @@
                   </a:schemeClr>
                 </a:solidFill>
               </a:rPr>
-              <a:t>    // 3. Conectar al Gateway</a:t>
-            </a:r>
-            <a:br>
+              <a:t>    const gateway = connect({ client, identity, signer });</a:t>
+            </a:r>
+          </a:p>
+          <a:p>
+            <a:pPr/>
+            <a:r>
               <a:rPr lang="es-ES" sz="1600" dirty="0">
                 <a:solidFill>
                   <a:schemeClr val="bg1">
@@ -15418,7 +16023,11 @@
                   </a:schemeClr>
                 </a:solidFill>
               </a:rPr>
-            </a:br>
+              <a:t/>
+            </a:r>
+          </a:p>
+          <a:p>
+            <a:pPr/>
             <a:r>
               <a:rPr lang="es-ES" sz="1600" dirty="0">
                 <a:solidFill>
@@ -15427,18 +16036,11 @@
                   </a:schemeClr>
                 </a:solidFill>
               </a:rPr>
-              <a:t>    </a:t>
-            </a:r>
-            <a:r>
-              <a:rPr lang="es-ES" sz="1600" dirty="0" err="1">
-                <a:solidFill>
-                  <a:schemeClr val="bg1">
-                    <a:lumMod val="95000"/>
-                  </a:schemeClr>
-                </a:solidFill>
-              </a:rPr>
-              <a:t>gw</a:t>
-            </a:r>
+              <a:t>    // 4. Obtener canal y contrato</a:t>
+            </a:r>
+          </a:p>
+          <a:p>
+            <a:pPr/>
             <a:r>
               <a:rPr lang="es-ES" sz="1600" dirty="0">
                 <a:solidFill>
@@ -15447,18 +16049,11 @@
                   </a:schemeClr>
                 </a:solidFill>
               </a:rPr>
-              <a:t>, _ := </a:t>
-            </a:r>
-            <a:r>
-              <a:rPr lang="es-ES" sz="1600" dirty="0" err="1">
-                <a:solidFill>
-                  <a:schemeClr val="bg1">
-                    <a:lumMod val="95000"/>
-                  </a:schemeClr>
-                </a:solidFill>
-              </a:rPr>
-              <a:t>client.Connect</a:t>
-            </a:r>
+              <a:t>    const network = gateway.getNetwork('mychannel');</a:t>
+            </a:r>
+          </a:p>
+          <a:p>
+            <a:pPr/>
             <a:r>
               <a:rPr lang="es-ES" sz="1600" dirty="0">
                 <a:solidFill>
@@ -15467,18 +16062,11 @@
                   </a:schemeClr>
                 </a:solidFill>
               </a:rPr>
-              <a:t>(id, </a:t>
-            </a:r>
-            <a:r>
-              <a:rPr lang="es-ES" sz="1600" dirty="0" err="1">
-                <a:solidFill>
-                  <a:schemeClr val="bg1">
-                    <a:lumMod val="95000"/>
-                  </a:schemeClr>
-                </a:solidFill>
-              </a:rPr>
-              <a:t>client.WithSign</a:t>
-            </a:r>
+              <a:t>    const contract = network.getContract('foodtrace');</a:t>
+            </a:r>
+          </a:p>
+          <a:p>
+            <a:pPr/>
             <a:r>
               <a:rPr lang="es-ES" sz="1600" dirty="0">
                 <a:solidFill>
@@ -15487,18 +16075,11 @@
                   </a:schemeClr>
                 </a:solidFill>
               </a:rPr>
-              <a:t>(</a:t>
-            </a:r>
-            <a:r>
-              <a:rPr lang="es-ES" sz="1600" dirty="0" err="1">
-                <a:solidFill>
-                  <a:schemeClr val="bg1">
-                    <a:lumMod val="95000"/>
-                  </a:schemeClr>
-                </a:solidFill>
-              </a:rPr>
-              <a:t>sign</a:t>
-            </a:r>
+              <a:t/>
+            </a:r>
+          </a:p>
+          <a:p>
+            <a:pPr/>
             <a:r>
               <a:rPr lang="es-ES" sz="1600" dirty="0">
                 <a:solidFill>
@@ -15507,9 +16088,12 @@
                   </a:schemeClr>
                 </a:solidFill>
               </a:rPr>
-              <a:t>),</a:t>
-            </a:r>
-            <a:br>
+              <a:t>    // 5. Evaluar (lectura)</a:t>
+            </a:r>
+          </a:p>
+          <a:p>
+            <a:pPr/>
+            <a:r>
               <a:rPr lang="es-ES" sz="1600" dirty="0">
                 <a:solidFill>
                   <a:schemeClr val="bg1">
@@ -15517,7 +16101,11 @@
                   </a:schemeClr>
                 </a:solidFill>
               </a:rPr>
-            </a:br>
+              <a:t>    const result = await contract.evaluateTransaction(</a:t>
+            </a:r>
+          </a:p>
+          <a:p>
+            <a:pPr/>
             <a:r>
               <a:rPr lang="es-ES" sz="1600" dirty="0">
                 <a:solidFill>
@@ -15526,18 +16114,11 @@
                   </a:schemeClr>
                 </a:solidFill>
               </a:rPr>
-              <a:t>        </a:t>
-            </a:r>
-            <a:r>
-              <a:rPr lang="es-ES" sz="1600" dirty="0" err="1">
-                <a:solidFill>
-                  <a:schemeClr val="bg1">
-                    <a:lumMod val="95000"/>
-                  </a:schemeClr>
-                </a:solidFill>
-              </a:rPr>
-              <a:t>client.WithClientConnection</a:t>
-            </a:r>
+              <a:t>        'GetAllLots');</a:t>
+            </a:r>
+          </a:p>
+          <a:p>
+            <a:pPr/>
             <a:r>
               <a:rPr lang="es-ES" sz="1600" dirty="0">
                 <a:solidFill>
@@ -15546,18 +16127,11 @@
                   </a:schemeClr>
                 </a:solidFill>
               </a:rPr>
-              <a:t>(</a:t>
-            </a:r>
-            <a:r>
-              <a:rPr lang="es-ES" sz="1600" dirty="0" err="1">
-                <a:solidFill>
-                  <a:schemeClr val="bg1">
-                    <a:lumMod val="95000"/>
-                  </a:schemeClr>
-                </a:solidFill>
-              </a:rPr>
-              <a:t>clientConnection</a:t>
-            </a:r>
+              <a:t>    console.log(new TextDecoder().decode(result));</a:t>
+            </a:r>
+          </a:p>
+          <a:p>
+            <a:pPr/>
             <a:r>
               <a:rPr lang="es-ES" sz="1600" dirty="0">
                 <a:solidFill>
@@ -15566,9 +16140,12 @@
                   </a:schemeClr>
                 </a:solidFill>
               </a:rPr>
-              <a:t>))</a:t>
-            </a:r>
-            <a:br>
+              <a:t/>
+            </a:r>
+          </a:p>
+          <a:p>
+            <a:pPr/>
+            <a:r>
               <a:rPr lang="es-ES" sz="1600" dirty="0">
                 <a:solidFill>
                   <a:schemeClr val="bg1">
@@ -15576,7 +16153,11 @@
                   </a:schemeClr>
                 </a:solidFill>
               </a:rPr>
-            </a:br>
+              <a:t>    // 6. Submit (escritura)</a:t>
+            </a:r>
+          </a:p>
+          <a:p>
+            <a:pPr/>
             <a:r>
               <a:rPr lang="es-ES" sz="1600" dirty="0">
                 <a:solidFill>
@@ -15585,18 +16166,11 @@
                   </a:schemeClr>
                 </a:solidFill>
               </a:rPr>
-              <a:t>    </a:t>
-            </a:r>
-            <a:r>
-              <a:rPr lang="es-ES" sz="1600" dirty="0" err="1">
-                <a:solidFill>
-                  <a:schemeClr val="bg1">
-                    <a:lumMod val="95000"/>
-                  </a:schemeClr>
-                </a:solidFill>
-              </a:rPr>
-              <a:t>defer</a:t>
-            </a:r>
+              <a:t>    await contract.submitTransaction('ProduceLot',</a:t>
+            </a:r>
+          </a:p>
+          <a:p>
+            <a:pPr/>
             <a:r>
               <a:rPr lang="es-ES" sz="1600" dirty="0">
                 <a:solidFill>
@@ -15605,18 +16179,11 @@
                   </a:schemeClr>
                 </a:solidFill>
               </a:rPr>
-              <a:t> </a:t>
-            </a:r>
-            <a:r>
-              <a:rPr lang="es-ES" sz="1600" dirty="0" err="1">
-                <a:solidFill>
-                  <a:schemeClr val="bg1">
-                    <a:lumMod val="95000"/>
-                  </a:schemeClr>
-                </a:solidFill>
-              </a:rPr>
-              <a:t>gw.Close</a:t>
-            </a:r>
+              <a:t>        'LOT-001', 'mango', 'Spain', '500.0');</a:t>
+            </a:r>
+          </a:p>
+          <a:p>
+            <a:pPr/>
             <a:r>
               <a:rPr lang="es-ES" sz="1600" dirty="0">
                 <a:solidFill>
@@ -15625,9 +16192,12 @@
                   </a:schemeClr>
                 </a:solidFill>
               </a:rPr>
-              <a:t>()</a:t>
-            </a:r>
-            <a:br>
+              <a:t>}</a:t>
+            </a:r>
+          </a:p>
+          <a:p>
+            <a:pPr/>
+            <a:r>
               <a:rPr lang="es-ES" sz="1600" dirty="0">
                 <a:solidFill>
                   <a:schemeClr val="bg1">
@@ -15635,8 +16205,12 @@
                   </a:schemeClr>
                 </a:solidFill>
               </a:rPr>
-            </a:br>
-            <a:br>
+              <a:t/>
+            </a:r>
+          </a:p>
+          <a:p>
+            <a:pPr/>
+            <a:r>
               <a:rPr lang="es-ES" sz="1600" dirty="0">
                 <a:solidFill>
                   <a:schemeClr val="bg1">
@@ -15644,468 +16218,8 @@
                   </a:schemeClr>
                 </a:solidFill>
               </a:rPr>
-            </a:br>
-            <a:r>
-              <a:rPr lang="es-ES" sz="1600" dirty="0">
-                <a:solidFill>
-                  <a:schemeClr val="bg1">
-                    <a:lumMod val="95000"/>
-                  </a:schemeClr>
-                </a:solidFill>
-              </a:rPr>
-              <a:t>    // 4. Obtener canal y contrato</a:t>
-            </a:r>
-            <a:br>
-              <a:rPr lang="es-ES" sz="1600" dirty="0">
-                <a:solidFill>
-                  <a:schemeClr val="bg1">
-                    <a:lumMod val="95000"/>
-                  </a:schemeClr>
-                </a:solidFill>
-              </a:rPr>
-            </a:br>
-            <a:r>
-              <a:rPr lang="es-ES" sz="1600" dirty="0">
-                <a:solidFill>
-                  <a:schemeClr val="bg1">
-                    <a:lumMod val="95000"/>
-                  </a:schemeClr>
-                </a:solidFill>
-              </a:rPr>
-              <a:t>    </a:t>
-            </a:r>
-            <a:r>
-              <a:rPr lang="es-ES" sz="1600" dirty="0" err="1">
-                <a:solidFill>
-                  <a:schemeClr val="bg1">
-                    <a:lumMod val="95000"/>
-                  </a:schemeClr>
-                </a:solidFill>
-              </a:rPr>
-              <a:t>network</a:t>
-            </a:r>
-            <a:r>
-              <a:rPr lang="es-ES" sz="1600" dirty="0">
-                <a:solidFill>
-                  <a:schemeClr val="bg1">
-                    <a:lumMod val="95000"/>
-                  </a:schemeClr>
-                </a:solidFill>
-              </a:rPr>
-              <a:t> := </a:t>
-            </a:r>
-            <a:r>
-              <a:rPr lang="es-ES" sz="1600" dirty="0" err="1">
-                <a:solidFill>
-                  <a:schemeClr val="bg1">
-                    <a:lumMod val="95000"/>
-                  </a:schemeClr>
-                </a:solidFill>
-              </a:rPr>
-              <a:t>gw.GetNetwork</a:t>
-            </a:r>
-            <a:r>
-              <a:rPr lang="es-ES" sz="1600" dirty="0">
-                <a:solidFill>
-                  <a:schemeClr val="bg1">
-                    <a:lumMod val="95000"/>
-                  </a:schemeClr>
-                </a:solidFill>
-              </a:rPr>
-              <a:t>("</a:t>
-            </a:r>
-            <a:r>
-              <a:rPr lang="es-ES" sz="1600" dirty="0" err="1">
-                <a:solidFill>
-                  <a:schemeClr val="bg1">
-                    <a:lumMod val="95000"/>
-                  </a:schemeClr>
-                </a:solidFill>
-              </a:rPr>
-              <a:t>mychannel</a:t>
-            </a:r>
-            <a:r>
-              <a:rPr lang="es-ES" sz="1600" dirty="0">
-                <a:solidFill>
-                  <a:schemeClr val="bg1">
-                    <a:lumMod val="95000"/>
-                  </a:schemeClr>
-                </a:solidFill>
-              </a:rPr>
-              <a:t>")</a:t>
-            </a:r>
-            <a:br>
-              <a:rPr lang="es-ES" sz="1600" dirty="0">
-                <a:solidFill>
-                  <a:schemeClr val="bg1">
-                    <a:lumMod val="95000"/>
-                  </a:schemeClr>
-                </a:solidFill>
-              </a:rPr>
-            </a:br>
-            <a:r>
-              <a:rPr lang="es-ES" sz="1600" dirty="0">
-                <a:solidFill>
-                  <a:schemeClr val="bg1">
-                    <a:lumMod val="95000"/>
-                  </a:schemeClr>
-                </a:solidFill>
-              </a:rPr>
-              <a:t>    </a:t>
-            </a:r>
-            <a:r>
-              <a:rPr lang="es-ES" sz="1600" dirty="0" err="1">
-                <a:solidFill>
-                  <a:schemeClr val="bg1">
-                    <a:lumMod val="95000"/>
-                  </a:schemeClr>
-                </a:solidFill>
-              </a:rPr>
-              <a:t>contract</a:t>
-            </a:r>
-            <a:r>
-              <a:rPr lang="es-ES" sz="1600" dirty="0">
-                <a:solidFill>
-                  <a:schemeClr val="bg1">
-                    <a:lumMod val="95000"/>
-                  </a:schemeClr>
-                </a:solidFill>
-              </a:rPr>
-              <a:t> := </a:t>
-            </a:r>
-            <a:r>
-              <a:rPr lang="es-ES" sz="1600" dirty="0" err="1">
-                <a:solidFill>
-                  <a:schemeClr val="bg1">
-                    <a:lumMod val="95000"/>
-                  </a:schemeClr>
-                </a:solidFill>
-              </a:rPr>
-              <a:t>network.GetContract</a:t>
-            </a:r>
-            <a:r>
-              <a:rPr lang="es-ES" sz="1600" dirty="0">
-                <a:solidFill>
-                  <a:schemeClr val="bg1">
-                    <a:lumMod val="95000"/>
-                  </a:schemeClr>
-                </a:solidFill>
-              </a:rPr>
-              <a:t>("</a:t>
-            </a:r>
-            <a:r>
-              <a:rPr lang="es-ES" sz="1600" dirty="0" err="1">
-                <a:solidFill>
-                  <a:schemeClr val="bg1">
-                    <a:lumMod val="95000"/>
-                  </a:schemeClr>
-                </a:solidFill>
-              </a:rPr>
-              <a:t>foodtrace</a:t>
-            </a:r>
-            <a:r>
-              <a:rPr lang="es-ES" sz="1600" dirty="0">
-                <a:solidFill>
-                  <a:schemeClr val="bg1">
-                    <a:lumMod val="95000"/>
-                  </a:schemeClr>
-                </a:solidFill>
-              </a:rPr>
-              <a:t>")</a:t>
-            </a:r>
-            <a:br>
-              <a:rPr lang="es-ES" sz="1600" dirty="0">
-                <a:solidFill>
-                  <a:schemeClr val="bg1">
-                    <a:lumMod val="95000"/>
-                  </a:schemeClr>
-                </a:solidFill>
-              </a:rPr>
-            </a:br>
-            <a:br>
-              <a:rPr lang="es-ES" sz="1600" dirty="0">
-                <a:solidFill>
-                  <a:schemeClr val="bg1">
-                    <a:lumMod val="95000"/>
-                  </a:schemeClr>
-                </a:solidFill>
-              </a:rPr>
-            </a:br>
-            <a:r>
-              <a:rPr lang="es-ES" sz="1600" dirty="0">
-                <a:solidFill>
-                  <a:schemeClr val="bg1">
-                    <a:lumMod val="95000"/>
-                  </a:schemeClr>
-                </a:solidFill>
-              </a:rPr>
-              <a:t>    // 5. Evaluar (lectura)</a:t>
-            </a:r>
-            <a:br>
-              <a:rPr lang="es-ES" sz="1600" dirty="0">
-                <a:solidFill>
-                  <a:schemeClr val="bg1">
-                    <a:lumMod val="95000"/>
-                  </a:schemeClr>
-                </a:solidFill>
-              </a:rPr>
-            </a:br>
-            <a:r>
-              <a:rPr lang="es-ES" sz="1600" dirty="0">
-                <a:solidFill>
-                  <a:schemeClr val="bg1">
-                    <a:lumMod val="95000"/>
-                  </a:schemeClr>
-                </a:solidFill>
-              </a:rPr>
-              <a:t>    </a:t>
-            </a:r>
-            <a:r>
-              <a:rPr lang="es-ES" sz="1600" dirty="0" err="1">
-                <a:solidFill>
-                  <a:schemeClr val="bg1">
-                    <a:lumMod val="95000"/>
-                  </a:schemeClr>
-                </a:solidFill>
-              </a:rPr>
-              <a:t>result</a:t>
-            </a:r>
-            <a:r>
-              <a:rPr lang="es-ES" sz="1600" dirty="0">
-                <a:solidFill>
-                  <a:schemeClr val="bg1">
-                    <a:lumMod val="95000"/>
-                  </a:schemeClr>
-                </a:solidFill>
-              </a:rPr>
-              <a:t>, _ := </a:t>
-            </a:r>
-            <a:r>
-              <a:rPr lang="es-ES" sz="1600" dirty="0" err="1">
-                <a:solidFill>
-                  <a:schemeClr val="bg1">
-                    <a:lumMod val="95000"/>
-                  </a:schemeClr>
-                </a:solidFill>
-              </a:rPr>
-              <a:t>contract.EvaluateTransaction</a:t>
-            </a:r>
-            <a:r>
-              <a:rPr lang="es-ES" sz="1600" dirty="0">
-                <a:solidFill>
-                  <a:schemeClr val="bg1">
-                    <a:lumMod val="95000"/>
-                  </a:schemeClr>
-                </a:solidFill>
-              </a:rPr>
-              <a:t>("</a:t>
-            </a:r>
-            <a:r>
-              <a:rPr lang="es-ES" sz="1600" dirty="0" err="1">
-                <a:solidFill>
-                  <a:schemeClr val="bg1">
-                    <a:lumMod val="95000"/>
-                  </a:schemeClr>
-                </a:solidFill>
-              </a:rPr>
-              <a:t>GetAllLots</a:t>
-            </a:r>
-            <a:r>
-              <a:rPr lang="es-ES" sz="1600" dirty="0">
-                <a:solidFill>
-                  <a:schemeClr val="bg1">
-                    <a:lumMod val="95000"/>
-                  </a:schemeClr>
-                </a:solidFill>
-              </a:rPr>
-              <a:t>")</a:t>
-            </a:r>
-            <a:br>
-              <a:rPr lang="es-ES" sz="1600" dirty="0">
-                <a:solidFill>
-                  <a:schemeClr val="bg1">
-                    <a:lumMod val="95000"/>
-                  </a:schemeClr>
-                </a:solidFill>
-              </a:rPr>
-            </a:br>
-            <a:br>
-              <a:rPr lang="es-ES" sz="1600" dirty="0">
-                <a:solidFill>
-                  <a:schemeClr val="bg1">
-                    <a:lumMod val="95000"/>
-                  </a:schemeClr>
-                </a:solidFill>
-              </a:rPr>
-            </a:br>
-            <a:r>
-              <a:rPr lang="es-ES" sz="1600" dirty="0">
-                <a:solidFill>
-                  <a:schemeClr val="bg1">
-                    <a:lumMod val="95000"/>
-                  </a:schemeClr>
-                </a:solidFill>
-              </a:rPr>
-              <a:t>    // 6. </a:t>
-            </a:r>
-            <a:r>
-              <a:rPr lang="es-ES" sz="1600" dirty="0" err="1">
-                <a:solidFill>
-                  <a:schemeClr val="bg1">
-                    <a:lumMod val="95000"/>
-                  </a:schemeClr>
-                </a:solidFill>
-              </a:rPr>
-              <a:t>Submit</a:t>
-            </a:r>
-            <a:r>
-              <a:rPr lang="es-ES" sz="1600" dirty="0">
-                <a:solidFill>
-                  <a:schemeClr val="bg1">
-                    <a:lumMod val="95000"/>
-                  </a:schemeClr>
-                </a:solidFill>
-              </a:rPr>
-              <a:t> (escritura)</a:t>
-            </a:r>
-            <a:br>
-              <a:rPr lang="es-ES" sz="1600" dirty="0">
-                <a:solidFill>
-                  <a:schemeClr val="bg1">
-                    <a:lumMod val="95000"/>
-                  </a:schemeClr>
-                </a:solidFill>
-              </a:rPr>
-            </a:br>
-            <a:r>
-              <a:rPr lang="es-ES" sz="1600" dirty="0">
-                <a:solidFill>
-                  <a:schemeClr val="bg1">
-                    <a:lumMod val="95000"/>
-                  </a:schemeClr>
-                </a:solidFill>
-              </a:rPr>
-              <a:t>    _, </a:t>
-            </a:r>
-            <a:r>
-              <a:rPr lang="es-ES" sz="1600" dirty="0" err="1">
-                <a:solidFill>
-                  <a:schemeClr val="bg1">
-                    <a:lumMod val="95000"/>
-                  </a:schemeClr>
-                </a:solidFill>
-              </a:rPr>
-              <a:t>err</a:t>
-            </a:r>
-            <a:r>
-              <a:rPr lang="es-ES" sz="1600" dirty="0">
-                <a:solidFill>
-                  <a:schemeClr val="bg1">
-                    <a:lumMod val="95000"/>
-                  </a:schemeClr>
-                </a:solidFill>
-              </a:rPr>
-              <a:t> := </a:t>
-            </a:r>
-            <a:r>
-              <a:rPr lang="es-ES" sz="1600" dirty="0" err="1">
-                <a:solidFill>
-                  <a:schemeClr val="bg1">
-                    <a:lumMod val="95000"/>
-                  </a:schemeClr>
-                </a:solidFill>
-              </a:rPr>
-              <a:t>contract.SubmitTransaction</a:t>
-            </a:r>
-            <a:r>
-              <a:rPr lang="es-ES" sz="1600" dirty="0">
-                <a:solidFill>
-                  <a:schemeClr val="bg1">
-                    <a:lumMod val="95000"/>
-                  </a:schemeClr>
-                </a:solidFill>
-              </a:rPr>
-              <a:t>("</a:t>
-            </a:r>
-            <a:r>
-              <a:rPr lang="es-ES" sz="1600" dirty="0" err="1">
-                <a:solidFill>
-                  <a:schemeClr val="bg1">
-                    <a:lumMod val="95000"/>
-                  </a:schemeClr>
-                </a:solidFill>
-              </a:rPr>
-              <a:t>ProduceLot</a:t>
-            </a:r>
-            <a:r>
-              <a:rPr lang="es-ES" sz="1600" dirty="0">
-                <a:solidFill>
-                  <a:schemeClr val="bg1">
-                    <a:lumMod val="95000"/>
-                  </a:schemeClr>
-                </a:solidFill>
-              </a:rPr>
-              <a:t>",</a:t>
-            </a:r>
-            <a:br>
-              <a:rPr lang="es-ES" sz="1600" dirty="0">
-                <a:solidFill>
-                  <a:schemeClr val="bg1">
-                    <a:lumMod val="95000"/>
-                  </a:schemeClr>
-                </a:solidFill>
-              </a:rPr>
-            </a:br>
-            <a:r>
-              <a:rPr lang="es-ES" sz="1600" dirty="0">
-                <a:solidFill>
-                  <a:schemeClr val="bg1">
-                    <a:lumMod val="95000"/>
-                  </a:schemeClr>
-                </a:solidFill>
-              </a:rPr>
-              <a:t>        "LOT-001", "mango", "</a:t>
-            </a:r>
-            <a:r>
-              <a:rPr lang="es-ES" sz="1600" dirty="0" err="1">
-                <a:solidFill>
-                  <a:schemeClr val="bg1">
-                    <a:lumMod val="95000"/>
-                  </a:schemeClr>
-                </a:solidFill>
-              </a:rPr>
-              <a:t>Spain</a:t>
-            </a:r>
-            <a:r>
-              <a:rPr lang="es-ES" sz="1600" dirty="0">
-                <a:solidFill>
-                  <a:schemeClr val="bg1">
-                    <a:lumMod val="95000"/>
-                  </a:schemeClr>
-                </a:solidFill>
-              </a:rPr>
-              <a:t>", "500.0")</a:t>
-            </a:r>
-            <a:br>
-              <a:rPr lang="es-ES" sz="1600" dirty="0">
-                <a:solidFill>
-                  <a:schemeClr val="bg1">
-                    <a:lumMod val="95000"/>
-                  </a:schemeClr>
-                </a:solidFill>
-              </a:rPr>
-            </a:br>
-            <a:r>
-              <a:rPr lang="es-ES" sz="1600" dirty="0">
-                <a:solidFill>
-                  <a:schemeClr val="bg1">
-                    <a:lumMod val="95000"/>
-                  </a:schemeClr>
-                </a:solidFill>
-              </a:rPr>
-              <a:t>}</a:t>
-            </a:r>
-            <a:endParaRPr lang="es-ES" sz="1600" dirty="0"/>
+              <a:t>main().catch(console.error);</a:t>
+            </a:r>
           </a:p>
         </p:txBody>
       </p:sp>

</xml_diff>